<commit_message>
Add interactive ECharts visualizations, chart PNGs, and update PPT with embedded charts
- Add 3 interactive ECharts HTML charts (radar/bar/pie) in charts/
- Add 3 chart PNG images in materials/
- Update PPT with embedded charts replacing placeholders
- Add chart generation script
- Update README with charts directory structure
</commit_message>
<xml_diff>
--- a/report/Gymshark品牌深度研究报告.pptx
+++ b/report/Gymshark品牌深度研究报告.pptx
@@ -5556,6 +5556,30 @@
           </a:p>
         </p:txBody>
       </p:sp>
+      <p:pic>
+        <p:nvPicPr>
+          <p:cNvPr id="13" name="Picture 12" descr="chart_pie.png"/>
+          <p:cNvPicPr>
+            <a:picLocks noChangeAspect="1"/>
+          </p:cNvPicPr>
+          <p:nvPr/>
+        </p:nvPicPr>
+        <p:blipFill>
+          <a:blip r:embed="rId2"/>
+          <a:stretch>
+            <a:fillRect/>
+          </a:stretch>
+        </p:blipFill>
+        <p:spPr>
+          <a:xfrm>
+            <a:off x="365760" y="1645920"/>
+            <a:ext cx="5303520" cy="5222781"/>
+          </a:xfrm>
+          <a:prstGeom prst="rect">
+            <a:avLst/>
+          </a:prstGeom>
+        </p:spPr>
+      </p:pic>
     </p:spTree>
   </p:cSld>
   <p:clrMapOvr>
@@ -8909,6 +8933,30 @@
           </a:p>
         </p:txBody>
       </p:sp>
+      <p:pic>
+        <p:nvPicPr>
+          <p:cNvPr id="11" name="Picture 10" descr="chart_radar.png"/>
+          <p:cNvPicPr>
+            <a:picLocks noChangeAspect="1"/>
+          </p:cNvPicPr>
+          <p:nvPr/>
+        </p:nvPicPr>
+        <p:blipFill>
+          <a:blip r:embed="rId2"/>
+          <a:stretch>
+            <a:fillRect/>
+          </a:stretch>
+        </p:blipFill>
+        <p:spPr>
+          <a:xfrm>
+            <a:off x="7132320" y="1188720"/>
+            <a:ext cx="4572000" cy="3841886"/>
+          </a:xfrm>
+          <a:prstGeom prst="rect">
+            <a:avLst/>
+          </a:prstGeom>
+        </p:spPr>
+      </p:pic>
     </p:spTree>
   </p:cSld>
   <p:clrMapOvr>
@@ -9981,6 +10029,30 @@
           </a:p>
         </p:txBody>
       </p:sp>
+      <p:pic>
+        <p:nvPicPr>
+          <p:cNvPr id="11" name="Picture 10" descr="chart_bar.png"/>
+          <p:cNvPicPr>
+            <a:picLocks noChangeAspect="1"/>
+          </p:cNvPicPr>
+          <p:nvPr/>
+        </p:nvPicPr>
+        <p:blipFill>
+          <a:blip r:embed="rId2"/>
+          <a:stretch>
+            <a:fillRect/>
+          </a:stretch>
+        </p:blipFill>
+        <p:spPr>
+          <a:xfrm>
+            <a:off x="6217920" y="1188720"/>
+            <a:ext cx="5486400" cy="3267472"/>
+          </a:xfrm>
+          <a:prstGeom prst="rect">
+            <a:avLst/>
+          </a:prstGeom>
+        </p:spPr>
+      </p:pic>
     </p:spTree>
   </p:cSld>
   <p:clrMapOvr>

</xml_diff>

<commit_message>
Update PPT: adjust layout and content
</commit_message>
<xml_diff>
--- a/report/Gymshark品牌深度研究报告.pptx
+++ b/report/Gymshark品牌深度研究报告.pptx
@@ -5,20 +5,20 @@
     <p:sldMasterId id="2147483648" r:id="rId1"/>
   </p:sldMasterIdLst>
   <p:sldIdLst>
-    <p:sldId id="256" r:id="rId7"/>
-    <p:sldId id="257" r:id="rId8"/>
-    <p:sldId id="258" r:id="rId9"/>
-    <p:sldId id="259" r:id="rId10"/>
-    <p:sldId id="260" r:id="rId11"/>
-    <p:sldId id="261" r:id="rId12"/>
-    <p:sldId id="262" r:id="rId13"/>
-    <p:sldId id="263" r:id="rId14"/>
-    <p:sldId id="264" r:id="rId15"/>
-    <p:sldId id="265" r:id="rId16"/>
-    <p:sldId id="266" r:id="rId17"/>
-    <p:sldId id="267" r:id="rId18"/>
+    <p:sldId id="256" r:id="rId2"/>
+    <p:sldId id="257" r:id="rId3"/>
+    <p:sldId id="258" r:id="rId4"/>
+    <p:sldId id="259" r:id="rId5"/>
+    <p:sldId id="260" r:id="rId6"/>
+    <p:sldId id="261" r:id="rId7"/>
+    <p:sldId id="262" r:id="rId8"/>
+    <p:sldId id="263" r:id="rId9"/>
+    <p:sldId id="264" r:id="rId10"/>
+    <p:sldId id="265" r:id="rId11"/>
+    <p:sldId id="266" r:id="rId12"/>
+    <p:sldId id="267" r:id="rId13"/>
   </p:sldIdLst>
-  <p:sldSz cx="12191695" cy="6858000" type="screen4x3"/>
+  <p:sldSz cx="12192000" cy="6858000"/>
   <p:notesSz cx="6858000" cy="9144000"/>
   <p:defaultTextStyle>
     <a:defPPr>
@@ -115,6 +115,22 @@
       </a:defRPr>
     </a:lvl9pPr>
   </p:defaultTextStyle>
+  <p:extLst>
+    <p:ext uri="{EFAFB233-063F-42B5-8137-9DF3F51BA10A}">
+      <p15:sldGuideLst xmlns:p15="http://schemas.microsoft.com/office/powerpoint/2012/main">
+        <p15:guide id="1" orient="horz" pos="2160">
+          <p15:clr>
+            <a:srgbClr val="A4A3A4"/>
+          </p15:clr>
+        </p15:guide>
+        <p15:guide id="2" pos="2880">
+          <p15:clr>
+            <a:srgbClr val="A4A3A4"/>
+          </p15:clr>
+        </p15:guide>
+      </p15:sldGuideLst>
+    </p:ext>
+  </p:extLst>
 </p:presentation>
 </file>
 
@@ -156,10 +172,9 @@
           <a:lstStyle/>
           <a:p>
             <a:r>
-              <a:rPr lang="en-US" smtClean="0"/>
+              <a:rPr lang="en-US"/>
               <a:t>Click to edit Master title style</a:t>
             </a:r>
-            <a:endParaRPr lang="en-US"/>
           </a:p>
         </p:txBody>
       </p:sp>
@@ -275,10 +290,9 @@
           </a:lstStyle>
           <a:p>
             <a:r>
-              <a:rPr lang="en-US" smtClean="0"/>
+              <a:rPr lang="en-US"/>
               <a:t>Click to edit Master subtitle style</a:t>
             </a:r>
-            <a:endParaRPr lang="en-US"/>
           </a:p>
         </p:txBody>
       </p:sp>
@@ -299,7 +313,7 @@
           <a:p>
             <a:fld id="{5BCAD085-E8A6-8845-BD4E-CB4CCA059FC4}" type="datetimeFigureOut">
               <a:rPr lang="en-US" smtClean="0"/>
-              <a:t>1/27/13</a:t>
+              <a:t>8/18/2026</a:t>
             </a:fld>
             <a:endParaRPr lang="en-US"/>
           </a:p>
@@ -393,10 +407,9 @@
           <a:lstStyle/>
           <a:p>
             <a:r>
-              <a:rPr lang="en-US" smtClean="0"/>
+              <a:rPr lang="en-US"/>
               <a:t>Click to edit Master title style</a:t>
             </a:r>
-            <a:endParaRPr lang="en-US"/>
           </a:p>
         </p:txBody>
       </p:sp>
@@ -417,38 +430,37 @@
           <a:p>
             <a:pPr lvl="0"/>
             <a:r>
-              <a:rPr lang="en-US" smtClean="0"/>
+              <a:rPr lang="en-US"/>
               <a:t>Click to edit Master text styles</a:t>
             </a:r>
           </a:p>
           <a:p>
             <a:pPr lvl="1"/>
             <a:r>
-              <a:rPr lang="en-US" smtClean="0"/>
+              <a:rPr lang="en-US"/>
               <a:t>Second level</a:t>
             </a:r>
           </a:p>
           <a:p>
             <a:pPr lvl="2"/>
             <a:r>
-              <a:rPr lang="en-US" smtClean="0"/>
+              <a:rPr lang="en-US"/>
               <a:t>Third level</a:t>
             </a:r>
           </a:p>
           <a:p>
             <a:pPr lvl="3"/>
             <a:r>
-              <a:rPr lang="en-US" smtClean="0"/>
+              <a:rPr lang="en-US"/>
               <a:t>Fourth level</a:t>
             </a:r>
           </a:p>
           <a:p>
             <a:pPr lvl="4"/>
             <a:r>
-              <a:rPr lang="en-US" smtClean="0"/>
+              <a:rPr lang="en-US"/>
               <a:t>Fifth level</a:t>
             </a:r>
-            <a:endParaRPr lang="en-US"/>
           </a:p>
         </p:txBody>
       </p:sp>
@@ -469,7 +481,7 @@
           <a:p>
             <a:fld id="{5BCAD085-E8A6-8845-BD4E-CB4CCA059FC4}" type="datetimeFigureOut">
               <a:rPr lang="en-US" smtClean="0"/>
-              <a:t>1/27/13</a:t>
+              <a:t>8/18/2026</a:t>
             </a:fld>
             <a:endParaRPr lang="en-US"/>
           </a:p>
@@ -568,10 +580,9 @@
           <a:lstStyle/>
           <a:p>
             <a:r>
-              <a:rPr lang="en-US" smtClean="0"/>
+              <a:rPr lang="en-US"/>
               <a:t>Click to edit Master title style</a:t>
             </a:r>
-            <a:endParaRPr lang="en-US"/>
           </a:p>
         </p:txBody>
       </p:sp>
@@ -597,38 +608,37 @@
           <a:p>
             <a:pPr lvl="0"/>
             <a:r>
-              <a:rPr lang="en-US" smtClean="0"/>
+              <a:rPr lang="en-US"/>
               <a:t>Click to edit Master text styles</a:t>
             </a:r>
           </a:p>
           <a:p>
             <a:pPr lvl="1"/>
             <a:r>
-              <a:rPr lang="en-US" smtClean="0"/>
+              <a:rPr lang="en-US"/>
               <a:t>Second level</a:t>
             </a:r>
           </a:p>
           <a:p>
             <a:pPr lvl="2"/>
             <a:r>
-              <a:rPr lang="en-US" smtClean="0"/>
+              <a:rPr lang="en-US"/>
               <a:t>Third level</a:t>
             </a:r>
           </a:p>
           <a:p>
             <a:pPr lvl="3"/>
             <a:r>
-              <a:rPr lang="en-US" smtClean="0"/>
+              <a:rPr lang="en-US"/>
               <a:t>Fourth level</a:t>
             </a:r>
           </a:p>
           <a:p>
             <a:pPr lvl="4"/>
             <a:r>
-              <a:rPr lang="en-US" smtClean="0"/>
+              <a:rPr lang="en-US"/>
               <a:t>Fifth level</a:t>
             </a:r>
-            <a:endParaRPr lang="en-US"/>
           </a:p>
         </p:txBody>
       </p:sp>
@@ -649,7 +659,7 @@
           <a:p>
             <a:fld id="{5BCAD085-E8A6-8845-BD4E-CB4CCA059FC4}" type="datetimeFigureOut">
               <a:rPr lang="en-US" smtClean="0"/>
-              <a:t>1/27/13</a:t>
+              <a:t>8/18/2026</a:t>
             </a:fld>
             <a:endParaRPr lang="en-US"/>
           </a:p>
@@ -743,10 +753,9 @@
           <a:lstStyle/>
           <a:p>
             <a:r>
-              <a:rPr lang="en-US" smtClean="0"/>
+              <a:rPr lang="en-US"/>
               <a:t>Click to edit Master title style</a:t>
             </a:r>
-            <a:endParaRPr lang="en-US"/>
           </a:p>
         </p:txBody>
       </p:sp>
@@ -767,38 +776,37 @@
           <a:p>
             <a:pPr lvl="0"/>
             <a:r>
-              <a:rPr lang="en-US" smtClean="0"/>
+              <a:rPr lang="en-US"/>
               <a:t>Click to edit Master text styles</a:t>
             </a:r>
           </a:p>
           <a:p>
             <a:pPr lvl="1"/>
             <a:r>
-              <a:rPr lang="en-US" smtClean="0"/>
+              <a:rPr lang="en-US"/>
               <a:t>Second level</a:t>
             </a:r>
           </a:p>
           <a:p>
             <a:pPr lvl="2"/>
             <a:r>
-              <a:rPr lang="en-US" smtClean="0"/>
+              <a:rPr lang="en-US"/>
               <a:t>Third level</a:t>
             </a:r>
           </a:p>
           <a:p>
             <a:pPr lvl="3"/>
             <a:r>
-              <a:rPr lang="en-US" smtClean="0"/>
+              <a:rPr lang="en-US"/>
               <a:t>Fourth level</a:t>
             </a:r>
           </a:p>
           <a:p>
             <a:pPr lvl="4"/>
             <a:r>
-              <a:rPr lang="en-US" smtClean="0"/>
+              <a:rPr lang="en-US"/>
               <a:t>Fifth level</a:t>
             </a:r>
-            <a:endParaRPr lang="en-US"/>
           </a:p>
         </p:txBody>
       </p:sp>
@@ -819,7 +827,7 @@
           <a:p>
             <a:fld id="{5BCAD085-E8A6-8845-BD4E-CB4CCA059FC4}" type="datetimeFigureOut">
               <a:rPr lang="en-US" smtClean="0"/>
-              <a:t>1/27/13</a:t>
+              <a:t>8/18/2026</a:t>
             </a:fld>
             <a:endParaRPr lang="en-US"/>
           </a:p>
@@ -922,10 +930,9 @@
           </a:lstStyle>
           <a:p>
             <a:r>
-              <a:rPr lang="en-US" smtClean="0"/>
+              <a:rPr lang="en-US"/>
               <a:t>Click to edit Master title style</a:t>
             </a:r>
-            <a:endParaRPr lang="en-US"/>
           </a:p>
         </p:txBody>
       </p:sp>
@@ -1042,7 +1049,7 @@
           <a:p>
             <a:pPr lvl="0"/>
             <a:r>
-              <a:rPr lang="en-US" smtClean="0"/>
+              <a:rPr lang="en-US"/>
               <a:t>Click to edit Master text styles</a:t>
             </a:r>
           </a:p>
@@ -1065,7 +1072,7 @@
           <a:p>
             <a:fld id="{5BCAD085-E8A6-8845-BD4E-CB4CCA059FC4}" type="datetimeFigureOut">
               <a:rPr lang="en-US" smtClean="0"/>
-              <a:t>1/27/13</a:t>
+              <a:t>8/18/2026</a:t>
             </a:fld>
             <a:endParaRPr lang="en-US"/>
           </a:p>
@@ -1159,10 +1166,9 @@
           <a:lstStyle/>
           <a:p>
             <a:r>
-              <a:rPr lang="en-US" smtClean="0"/>
+              <a:rPr lang="en-US"/>
               <a:t>Click to edit Master title style</a:t>
             </a:r>
-            <a:endParaRPr lang="en-US"/>
           </a:p>
         </p:txBody>
       </p:sp>
@@ -1216,38 +1222,37 @@
           <a:p>
             <a:pPr lvl="0"/>
             <a:r>
-              <a:rPr lang="en-US" smtClean="0"/>
+              <a:rPr lang="en-US"/>
               <a:t>Click to edit Master text styles</a:t>
             </a:r>
           </a:p>
           <a:p>
             <a:pPr lvl="1"/>
             <a:r>
-              <a:rPr lang="en-US" smtClean="0"/>
+              <a:rPr lang="en-US"/>
               <a:t>Second level</a:t>
             </a:r>
           </a:p>
           <a:p>
             <a:pPr lvl="2"/>
             <a:r>
-              <a:rPr lang="en-US" smtClean="0"/>
+              <a:rPr lang="en-US"/>
               <a:t>Third level</a:t>
             </a:r>
           </a:p>
           <a:p>
             <a:pPr lvl="3"/>
             <a:r>
-              <a:rPr lang="en-US" smtClean="0"/>
+              <a:rPr lang="en-US"/>
               <a:t>Fourth level</a:t>
             </a:r>
           </a:p>
           <a:p>
             <a:pPr lvl="4"/>
             <a:r>
-              <a:rPr lang="en-US" smtClean="0"/>
+              <a:rPr lang="en-US"/>
               <a:t>Fifth level</a:t>
             </a:r>
-            <a:endParaRPr lang="en-US"/>
           </a:p>
         </p:txBody>
       </p:sp>
@@ -1301,38 +1306,37 @@
           <a:p>
             <a:pPr lvl="0"/>
             <a:r>
-              <a:rPr lang="en-US" smtClean="0"/>
+              <a:rPr lang="en-US"/>
               <a:t>Click to edit Master text styles</a:t>
             </a:r>
           </a:p>
           <a:p>
             <a:pPr lvl="1"/>
             <a:r>
-              <a:rPr lang="en-US" smtClean="0"/>
+              <a:rPr lang="en-US"/>
               <a:t>Second level</a:t>
             </a:r>
           </a:p>
           <a:p>
             <a:pPr lvl="2"/>
             <a:r>
-              <a:rPr lang="en-US" smtClean="0"/>
+              <a:rPr lang="en-US"/>
               <a:t>Third level</a:t>
             </a:r>
           </a:p>
           <a:p>
             <a:pPr lvl="3"/>
             <a:r>
-              <a:rPr lang="en-US" smtClean="0"/>
+              <a:rPr lang="en-US"/>
               <a:t>Fourth level</a:t>
             </a:r>
           </a:p>
           <a:p>
             <a:pPr lvl="4"/>
             <a:r>
-              <a:rPr lang="en-US" smtClean="0"/>
+              <a:rPr lang="en-US"/>
               <a:t>Fifth level</a:t>
             </a:r>
-            <a:endParaRPr lang="en-US"/>
           </a:p>
         </p:txBody>
       </p:sp>
@@ -1353,7 +1357,7 @@
           <a:p>
             <a:fld id="{5BCAD085-E8A6-8845-BD4E-CB4CCA059FC4}" type="datetimeFigureOut">
               <a:rPr lang="en-US" smtClean="0"/>
-              <a:t>1/27/13</a:t>
+              <a:t>8/18/2026</a:t>
             </a:fld>
             <a:endParaRPr lang="en-US"/>
           </a:p>
@@ -1451,10 +1455,9 @@
           </a:lstStyle>
           <a:p>
             <a:r>
-              <a:rPr lang="en-US" smtClean="0"/>
+              <a:rPr lang="en-US"/>
               <a:t>Click to edit Master title style</a:t>
             </a:r>
-            <a:endParaRPr lang="en-US"/>
           </a:p>
         </p:txBody>
       </p:sp>
@@ -1517,7 +1520,7 @@
           <a:p>
             <a:pPr lvl="0"/>
             <a:r>
-              <a:rPr lang="en-US" smtClean="0"/>
+              <a:rPr lang="en-US"/>
               <a:t>Click to edit Master text styles</a:t>
             </a:r>
           </a:p>
@@ -1573,38 +1576,37 @@
           <a:p>
             <a:pPr lvl="0"/>
             <a:r>
-              <a:rPr lang="en-US" smtClean="0"/>
+              <a:rPr lang="en-US"/>
               <a:t>Click to edit Master text styles</a:t>
             </a:r>
           </a:p>
           <a:p>
             <a:pPr lvl="1"/>
             <a:r>
-              <a:rPr lang="en-US" smtClean="0"/>
+              <a:rPr lang="en-US"/>
               <a:t>Second level</a:t>
             </a:r>
           </a:p>
           <a:p>
             <a:pPr lvl="2"/>
             <a:r>
-              <a:rPr lang="en-US" smtClean="0"/>
+              <a:rPr lang="en-US"/>
               <a:t>Third level</a:t>
             </a:r>
           </a:p>
           <a:p>
             <a:pPr lvl="3"/>
             <a:r>
-              <a:rPr lang="en-US" smtClean="0"/>
+              <a:rPr lang="en-US"/>
               <a:t>Fourth level</a:t>
             </a:r>
           </a:p>
           <a:p>
             <a:pPr lvl="4"/>
             <a:r>
-              <a:rPr lang="en-US" smtClean="0"/>
+              <a:rPr lang="en-US"/>
               <a:t>Fifth level</a:t>
             </a:r>
-            <a:endParaRPr lang="en-US"/>
           </a:p>
         </p:txBody>
       </p:sp>
@@ -1667,7 +1669,7 @@
           <a:p>
             <a:pPr lvl="0"/>
             <a:r>
-              <a:rPr lang="en-US" smtClean="0"/>
+              <a:rPr lang="en-US"/>
               <a:t>Click to edit Master text styles</a:t>
             </a:r>
           </a:p>
@@ -1723,38 +1725,37 @@
           <a:p>
             <a:pPr lvl="0"/>
             <a:r>
-              <a:rPr lang="en-US" smtClean="0"/>
+              <a:rPr lang="en-US"/>
               <a:t>Click to edit Master text styles</a:t>
             </a:r>
           </a:p>
           <a:p>
             <a:pPr lvl="1"/>
             <a:r>
-              <a:rPr lang="en-US" smtClean="0"/>
+              <a:rPr lang="en-US"/>
               <a:t>Second level</a:t>
             </a:r>
           </a:p>
           <a:p>
             <a:pPr lvl="2"/>
             <a:r>
-              <a:rPr lang="en-US" smtClean="0"/>
+              <a:rPr lang="en-US"/>
               <a:t>Third level</a:t>
             </a:r>
           </a:p>
           <a:p>
             <a:pPr lvl="3"/>
             <a:r>
-              <a:rPr lang="en-US" smtClean="0"/>
+              <a:rPr lang="en-US"/>
               <a:t>Fourth level</a:t>
             </a:r>
           </a:p>
           <a:p>
             <a:pPr lvl="4"/>
             <a:r>
-              <a:rPr lang="en-US" smtClean="0"/>
+              <a:rPr lang="en-US"/>
               <a:t>Fifth level</a:t>
             </a:r>
-            <a:endParaRPr lang="en-US"/>
           </a:p>
         </p:txBody>
       </p:sp>
@@ -1775,7 +1776,7 @@
           <a:p>
             <a:fld id="{5BCAD085-E8A6-8845-BD4E-CB4CCA059FC4}" type="datetimeFigureOut">
               <a:rPr lang="en-US" smtClean="0"/>
-              <a:t>1/27/13</a:t>
+              <a:t>8/18/2026</a:t>
             </a:fld>
             <a:endParaRPr lang="en-US"/>
           </a:p>
@@ -1869,10 +1870,9 @@
           <a:lstStyle/>
           <a:p>
             <a:r>
-              <a:rPr lang="en-US" smtClean="0"/>
+              <a:rPr lang="en-US"/>
               <a:t>Click to edit Master title style</a:t>
             </a:r>
-            <a:endParaRPr lang="en-US"/>
           </a:p>
         </p:txBody>
       </p:sp>
@@ -1893,7 +1893,7 @@
           <a:p>
             <a:fld id="{5BCAD085-E8A6-8845-BD4E-CB4CCA059FC4}" type="datetimeFigureOut">
               <a:rPr lang="en-US" smtClean="0"/>
-              <a:t>1/27/13</a:t>
+              <a:t>8/18/2026</a:t>
             </a:fld>
             <a:endParaRPr lang="en-US"/>
           </a:p>
@@ -1988,7 +1988,7 @@
           <a:p>
             <a:fld id="{5BCAD085-E8A6-8845-BD4E-CB4CCA059FC4}" type="datetimeFigureOut">
               <a:rPr lang="en-US" smtClean="0"/>
-              <a:t>1/27/13</a:t>
+              <a:t>8/18/2026</a:t>
             </a:fld>
             <a:endParaRPr lang="en-US"/>
           </a:p>
@@ -2091,10 +2091,9 @@
           </a:lstStyle>
           <a:p>
             <a:r>
-              <a:rPr lang="en-US" smtClean="0"/>
+              <a:rPr lang="en-US"/>
               <a:t>Click to edit Master title style</a:t>
             </a:r>
-            <a:endParaRPr lang="en-US"/>
           </a:p>
         </p:txBody>
       </p:sp>
@@ -2148,38 +2147,37 @@
           <a:p>
             <a:pPr lvl="0"/>
             <a:r>
-              <a:rPr lang="en-US" smtClean="0"/>
+              <a:rPr lang="en-US"/>
               <a:t>Click to edit Master text styles</a:t>
             </a:r>
           </a:p>
           <a:p>
             <a:pPr lvl="1"/>
             <a:r>
-              <a:rPr lang="en-US" smtClean="0"/>
+              <a:rPr lang="en-US"/>
               <a:t>Second level</a:t>
             </a:r>
           </a:p>
           <a:p>
             <a:pPr lvl="2"/>
             <a:r>
-              <a:rPr lang="en-US" smtClean="0"/>
+              <a:rPr lang="en-US"/>
               <a:t>Third level</a:t>
             </a:r>
           </a:p>
           <a:p>
             <a:pPr lvl="3"/>
             <a:r>
-              <a:rPr lang="en-US" smtClean="0"/>
+              <a:rPr lang="en-US"/>
               <a:t>Fourth level</a:t>
             </a:r>
           </a:p>
           <a:p>
             <a:pPr lvl="4"/>
             <a:r>
-              <a:rPr lang="en-US" smtClean="0"/>
+              <a:rPr lang="en-US"/>
               <a:t>Fifth level</a:t>
             </a:r>
-            <a:endParaRPr lang="en-US"/>
           </a:p>
         </p:txBody>
       </p:sp>
@@ -2242,7 +2240,7 @@
           <a:p>
             <a:pPr lvl="0"/>
             <a:r>
-              <a:rPr lang="en-US" smtClean="0"/>
+              <a:rPr lang="en-US"/>
               <a:t>Click to edit Master text styles</a:t>
             </a:r>
           </a:p>
@@ -2265,7 +2263,7 @@
           <a:p>
             <a:fld id="{5BCAD085-E8A6-8845-BD4E-CB4CCA059FC4}" type="datetimeFigureOut">
               <a:rPr lang="en-US" smtClean="0"/>
-              <a:t>1/27/13</a:t>
+              <a:t>8/18/2026</a:t>
             </a:fld>
             <a:endParaRPr lang="en-US"/>
           </a:p>
@@ -2368,10 +2366,9 @@
           </a:lstStyle>
           <a:p>
             <a:r>
-              <a:rPr lang="en-US" smtClean="0"/>
+              <a:rPr lang="en-US"/>
               <a:t>Click to edit Master title style</a:t>
             </a:r>
-            <a:endParaRPr lang="en-US"/>
           </a:p>
         </p:txBody>
       </p:sp>
@@ -2495,7 +2492,7 @@
           <a:p>
             <a:pPr lvl="0"/>
             <a:r>
-              <a:rPr lang="en-US" smtClean="0"/>
+              <a:rPr lang="en-US"/>
               <a:t>Click to edit Master text styles</a:t>
             </a:r>
           </a:p>
@@ -2518,7 +2515,7 @@
           <a:p>
             <a:fld id="{5BCAD085-E8A6-8845-BD4E-CB4CCA059FC4}" type="datetimeFigureOut">
               <a:rPr lang="en-US" smtClean="0"/>
-              <a:t>1/27/13</a:t>
+              <a:t>8/18/2026</a:t>
             </a:fld>
             <a:endParaRPr lang="en-US"/>
           </a:p>
@@ -2627,10 +2624,9 @@
           <a:lstStyle/>
           <a:p>
             <a:r>
-              <a:rPr lang="en-US" smtClean="0"/>
+              <a:rPr lang="en-US"/>
               <a:t>Click to edit Master title style</a:t>
             </a:r>
-            <a:endParaRPr lang="en-US"/>
           </a:p>
         </p:txBody>
       </p:sp>
@@ -2661,38 +2657,37 @@
           <a:p>
             <a:pPr lvl="0"/>
             <a:r>
-              <a:rPr lang="en-US" smtClean="0"/>
+              <a:rPr lang="en-US"/>
               <a:t>Click to edit Master text styles</a:t>
             </a:r>
           </a:p>
           <a:p>
             <a:pPr lvl="1"/>
             <a:r>
-              <a:rPr lang="en-US" smtClean="0"/>
+              <a:rPr lang="en-US"/>
               <a:t>Second level</a:t>
             </a:r>
           </a:p>
           <a:p>
             <a:pPr lvl="2"/>
             <a:r>
-              <a:rPr lang="en-US" smtClean="0"/>
+              <a:rPr lang="en-US"/>
               <a:t>Third level</a:t>
             </a:r>
           </a:p>
           <a:p>
             <a:pPr lvl="3"/>
             <a:r>
-              <a:rPr lang="en-US" smtClean="0"/>
+              <a:rPr lang="en-US"/>
               <a:t>Fourth level</a:t>
             </a:r>
           </a:p>
           <a:p>
             <a:pPr lvl="4"/>
             <a:r>
-              <a:rPr lang="en-US" smtClean="0"/>
+              <a:rPr lang="en-US"/>
               <a:t>Fifth level</a:t>
             </a:r>
-            <a:endParaRPr lang="en-US"/>
           </a:p>
         </p:txBody>
       </p:sp>
@@ -2731,7 +2726,7 @@
           <a:p>
             <a:fld id="{5BCAD085-E8A6-8845-BD4E-CB4CCA059FC4}" type="datetimeFigureOut">
               <a:rPr lang="en-US" smtClean="0"/>
-              <a:t>1/27/13</a:t>
+              <a:t>8/18/2026</a:t>
             </a:fld>
             <a:endParaRPr lang="en-US"/>
           </a:p>
@@ -3090,7 +3085,7 @@
 </file>
 
 <file path=ppt/slides/slide1.xml><?xml version="1.0" encoding="utf-8"?>
-<p:sld xmlns:a="http://schemas.openxmlformats.org/drawingml/2006/main" xmlns:p="http://schemas.openxmlformats.org/presentationml/2006/main" xmlns:r="http://schemas.openxmlformats.org/officeDocument/2006/relationships">
+<p:sld xmlns:a="http://schemas.openxmlformats.org/drawingml/2006/main" xmlns:r="http://schemas.openxmlformats.org/officeDocument/2006/relationships" xmlns:p="http://schemas.openxmlformats.org/presentationml/2006/main">
   <p:cSld>
     <p:bg>
       <p:bgPr>
@@ -3106,7 +3101,14 @@
         <p:cNvGrpSpPr/>
         <p:nvPr/>
       </p:nvGrpSpPr>
-      <p:grpSpPr/>
+      <p:grpSpPr>
+        <a:xfrm>
+          <a:off x="0" y="0"/>
+          <a:ext cx="0" cy="0"/>
+          <a:chOff x="0" y="0"/>
+          <a:chExt cx="0" cy="0"/>
+        </a:xfrm>
+      </p:grpSpPr>
       <p:sp>
         <p:nvSpPr>
           <p:cNvPr id="2" name="Rectangle 1"/>
@@ -3147,6 +3149,7 @@
           <a:lstStyle/>
           <a:p>
             <a:pPr algn="ctr"/>
+            <a:endParaRPr/>
           </a:p>
         </p:txBody>
       </p:sp>
@@ -3339,7 +3342,7 @@
 </file>
 
 <file path=ppt/slides/slide10.xml><?xml version="1.0" encoding="utf-8"?>
-<p:sld xmlns:a="http://schemas.openxmlformats.org/drawingml/2006/main" xmlns:p="http://schemas.openxmlformats.org/presentationml/2006/main" xmlns:r="http://schemas.openxmlformats.org/officeDocument/2006/relationships">
+<p:sld xmlns:a="http://schemas.openxmlformats.org/drawingml/2006/main" xmlns:r="http://schemas.openxmlformats.org/officeDocument/2006/relationships" xmlns:p="http://schemas.openxmlformats.org/presentationml/2006/main">
   <p:cSld>
     <p:bg>
       <p:bgPr>
@@ -3355,7 +3358,14 @@
         <p:cNvGrpSpPr/>
         <p:nvPr/>
       </p:nvGrpSpPr>
-      <p:grpSpPr/>
+      <p:grpSpPr>
+        <a:xfrm>
+          <a:off x="0" y="0"/>
+          <a:ext cx="0" cy="0"/>
+          <a:chOff x="0" y="0"/>
+          <a:chExt cx="0" cy="0"/>
+        </a:xfrm>
+      </p:grpSpPr>
       <p:sp>
         <p:nvSpPr>
           <p:cNvPr id="2" name="Rectangle 1"/>
@@ -3396,6 +3406,7 @@
           <a:lstStyle/>
           <a:p>
             <a:pPr algn="ctr"/>
+            <a:endParaRPr/>
           </a:p>
         </p:txBody>
       </p:sp>
@@ -3517,7 +3528,7 @@
         </p:nvGraphicFramePr>
         <p:xfrm>
           <a:off x="548640" y="1737360"/>
-          <a:ext cx="5486400" cy="1463040"/>
+          <a:ext cx="5486400" cy="1524000"/>
         </p:xfrm>
         <a:graphic>
           <a:graphicData uri="http://schemas.openxmlformats.org/drawingml/2006/table">
@@ -3526,10 +3537,34 @@
                 <a:tableStyleId>{5C22544A-7EE6-4342-B048-85BDC9FD1C3A}</a:tableStyleId>
               </a:tblPr>
               <a:tblGrid>
-                <a:gridCol w="1371600"/>
-                <a:gridCol w="1371600"/>
-                <a:gridCol w="1371600"/>
-                <a:gridCol w="1371600"/>
+                <a:gridCol w="1371600">
+                  <a:extLst>
+                    <a:ext uri="{9D8B030D-6E8A-4147-A177-3AD203B41FA5}">
+                      <a16:colId xmlns:a16="http://schemas.microsoft.com/office/drawing/2014/main" val="20000"/>
+                    </a:ext>
+                  </a:extLst>
+                </a:gridCol>
+                <a:gridCol w="1371600">
+                  <a:extLst>
+                    <a:ext uri="{9D8B030D-6E8A-4147-A177-3AD203B41FA5}">
+                      <a16:colId xmlns:a16="http://schemas.microsoft.com/office/drawing/2014/main" val="20001"/>
+                    </a:ext>
+                  </a:extLst>
+                </a:gridCol>
+                <a:gridCol w="1371600">
+                  <a:extLst>
+                    <a:ext uri="{9D8B030D-6E8A-4147-A177-3AD203B41FA5}">
+                      <a16:colId xmlns:a16="http://schemas.microsoft.com/office/drawing/2014/main" val="20002"/>
+                    </a:ext>
+                  </a:extLst>
+                </a:gridCol>
+                <a:gridCol w="1371600">
+                  <a:extLst>
+                    <a:ext uri="{9D8B030D-6E8A-4147-A177-3AD203B41FA5}">
+                      <a16:colId xmlns:a16="http://schemas.microsoft.com/office/drawing/2014/main" val="20003"/>
+                    </a:ext>
+                  </a:extLst>
+                </a:gridCol>
               </a:tblGrid>
               <a:tr h="487680">
                 <a:tc>
@@ -3628,6 +3663,11 @@
                     </a:solidFill>
                   </a:tcPr>
                 </a:tc>
+                <a:extLst>
+                  <a:ext uri="{0D108BD9-81ED-4DB2-BD59-A6C34878D82A}">
+                    <a16:rowId xmlns:a16="http://schemas.microsoft.com/office/drawing/2014/main" val="10000"/>
+                  </a:ext>
+                </a:extLst>
               </a:tr>
               <a:tr h="487680">
                 <a:tc>
@@ -3710,6 +3750,11 @@
                   </a:txBody>
                   <a:tcPr/>
                 </a:tc>
+                <a:extLst>
+                  <a:ext uri="{0D108BD9-81ED-4DB2-BD59-A6C34878D82A}">
+                    <a16:rowId xmlns:a16="http://schemas.microsoft.com/office/drawing/2014/main" val="10001"/>
+                  </a:ext>
+                </a:extLst>
               </a:tr>
               <a:tr h="487680">
                 <a:tc>
@@ -3808,6 +3853,11 @@
                     </a:solidFill>
                   </a:tcPr>
                 </a:tc>
+                <a:extLst>
+                  <a:ext uri="{0D108BD9-81ED-4DB2-BD59-A6C34878D82A}">
+                    <a16:rowId xmlns:a16="http://schemas.microsoft.com/office/drawing/2014/main" val="10002"/>
+                  </a:ext>
+                </a:extLst>
               </a:tr>
             </a:tbl>
           </a:graphicData>
@@ -4060,10 +4110,34 @@
                 <a:tableStyleId>{5C22544A-7EE6-4342-B048-85BDC9FD1C3A}</a:tableStyleId>
               </a:tblPr>
               <a:tblGrid>
-                <a:gridCol w="1257300"/>
-                <a:gridCol w="1257300"/>
-                <a:gridCol w="1257300"/>
-                <a:gridCol w="1257300"/>
+                <a:gridCol w="1257300">
+                  <a:extLst>
+                    <a:ext uri="{9D8B030D-6E8A-4147-A177-3AD203B41FA5}">
+                      <a16:colId xmlns:a16="http://schemas.microsoft.com/office/drawing/2014/main" val="20000"/>
+                    </a:ext>
+                  </a:extLst>
+                </a:gridCol>
+                <a:gridCol w="1257300">
+                  <a:extLst>
+                    <a:ext uri="{9D8B030D-6E8A-4147-A177-3AD203B41FA5}">
+                      <a16:colId xmlns:a16="http://schemas.microsoft.com/office/drawing/2014/main" val="20001"/>
+                    </a:ext>
+                  </a:extLst>
+                </a:gridCol>
+                <a:gridCol w="1257300">
+                  <a:extLst>
+                    <a:ext uri="{9D8B030D-6E8A-4147-A177-3AD203B41FA5}">
+                      <a16:colId xmlns:a16="http://schemas.microsoft.com/office/drawing/2014/main" val="20002"/>
+                    </a:ext>
+                  </a:extLst>
+                </a:gridCol>
+                <a:gridCol w="1257300">
+                  <a:extLst>
+                    <a:ext uri="{9D8B030D-6E8A-4147-A177-3AD203B41FA5}">
+                      <a16:colId xmlns:a16="http://schemas.microsoft.com/office/drawing/2014/main" val="20003"/>
+                    </a:ext>
+                  </a:extLst>
+                </a:gridCol>
               </a:tblGrid>
               <a:tr h="402336">
                 <a:tc>
@@ -4162,6 +4236,11 @@
                     </a:solidFill>
                   </a:tcPr>
                 </a:tc>
+                <a:extLst>
+                  <a:ext uri="{0D108BD9-81ED-4DB2-BD59-A6C34878D82A}">
+                    <a16:rowId xmlns:a16="http://schemas.microsoft.com/office/drawing/2014/main" val="10000"/>
+                  </a:ext>
+                </a:extLst>
               </a:tr>
               <a:tr h="402336">
                 <a:tc>
@@ -4244,6 +4323,11 @@
                   </a:txBody>
                   <a:tcPr/>
                 </a:tc>
+                <a:extLst>
+                  <a:ext uri="{0D108BD9-81ED-4DB2-BD59-A6C34878D82A}">
+                    <a16:rowId xmlns:a16="http://schemas.microsoft.com/office/drawing/2014/main" val="10001"/>
+                  </a:ext>
+                </a:extLst>
               </a:tr>
               <a:tr h="402336">
                 <a:tc>
@@ -4342,6 +4426,11 @@
                     </a:solidFill>
                   </a:tcPr>
                 </a:tc>
+                <a:extLst>
+                  <a:ext uri="{0D108BD9-81ED-4DB2-BD59-A6C34878D82A}">
+                    <a16:rowId xmlns:a16="http://schemas.microsoft.com/office/drawing/2014/main" val="10002"/>
+                  </a:ext>
+                </a:extLst>
               </a:tr>
               <a:tr h="402336">
                 <a:tc>
@@ -4424,6 +4513,11 @@
                   </a:txBody>
                   <a:tcPr/>
                 </a:tc>
+                <a:extLst>
+                  <a:ext uri="{0D108BD9-81ED-4DB2-BD59-A6C34878D82A}">
+                    <a16:rowId xmlns:a16="http://schemas.microsoft.com/office/drawing/2014/main" val="10003"/>
+                  </a:ext>
+                </a:extLst>
               </a:tr>
               <a:tr h="402336">
                 <a:tc>
@@ -4522,6 +4616,11 @@
                     </a:solidFill>
                   </a:tcPr>
                 </a:tc>
+                <a:extLst>
+                  <a:ext uri="{0D108BD9-81ED-4DB2-BD59-A6C34878D82A}">
+                    <a16:rowId xmlns:a16="http://schemas.microsoft.com/office/drawing/2014/main" val="10004"/>
+                  </a:ext>
+                </a:extLst>
               </a:tr>
             </a:tbl>
           </a:graphicData>
@@ -4652,7 +4751,7 @@
 </file>
 
 <file path=ppt/slides/slide11.xml><?xml version="1.0" encoding="utf-8"?>
-<p:sld xmlns:a="http://schemas.openxmlformats.org/drawingml/2006/main" xmlns:p="http://schemas.openxmlformats.org/presentationml/2006/main" xmlns:r="http://schemas.openxmlformats.org/officeDocument/2006/relationships">
+<p:sld xmlns:a="http://schemas.openxmlformats.org/drawingml/2006/main" xmlns:r="http://schemas.openxmlformats.org/officeDocument/2006/relationships" xmlns:p="http://schemas.openxmlformats.org/presentationml/2006/main">
   <p:cSld>
     <p:bg>
       <p:bgPr>
@@ -4668,7 +4767,14 @@
         <p:cNvGrpSpPr/>
         <p:nvPr/>
       </p:nvGrpSpPr>
-      <p:grpSpPr/>
+      <p:grpSpPr>
+        <a:xfrm>
+          <a:off x="0" y="0"/>
+          <a:ext cx="0" cy="0"/>
+          <a:chOff x="0" y="0"/>
+          <a:chExt cx="0" cy="0"/>
+        </a:xfrm>
+      </p:grpSpPr>
       <p:sp>
         <p:nvSpPr>
           <p:cNvPr id="2" name="Rectangle 1"/>
@@ -4709,6 +4815,7 @@
           <a:lstStyle/>
           <a:p>
             <a:pPr algn="ctr"/>
+            <a:endParaRPr/>
           </a:p>
         </p:txBody>
       </p:sp>
@@ -4862,6 +4969,7 @@
           <a:lstStyle/>
           <a:p>
             <a:pPr algn="ctr"/>
+            <a:endParaRPr/>
           </a:p>
         </p:txBody>
       </p:sp>
@@ -4873,7 +4981,7 @@
         </p:nvSpPr>
         <p:spPr>
           <a:xfrm>
-            <a:off x="731520" y="1920240"/>
+            <a:off x="-581780" y="1977860"/>
             <a:ext cx="4572000" cy="365760"/>
           </a:xfrm>
           <a:prstGeom prst="rect">
@@ -4896,8 +5004,10 @@
               </a:defRPr>
             </a:pPr>
             <a:r>
+              <a:rPr dirty="0" err="1"/>
               <a:t>用户痛点饼图</a:t>
             </a:r>
+            <a:endParaRPr dirty="0"/>
           </a:p>
         </p:txBody>
       </p:sp>
@@ -4909,7 +5019,7 @@
         </p:nvSpPr>
         <p:spPr>
           <a:xfrm>
-            <a:off x="731520" y="2926080"/>
+            <a:off x="-581780" y="2724176"/>
             <a:ext cx="4572000" cy="1645920"/>
           </a:xfrm>
           <a:prstGeom prst="rect">
@@ -4932,20 +5042,68 @@
               </a:defRPr>
             </a:pPr>
             <a:r>
-              <a:t>【图表占位】</a:t>
-            </a:r>
-            <a:br/>
-            <a:br/>
-            <a:r>
-              <a:t>尺码不一致 30% | 面料耐用性 25%</a:t>
-            </a:r>
-            <a:br/>
-            <a:r>
-              <a:t>客服售后 20% | 限量发售/APP 15%</a:t>
-            </a:r>
-            <a:br/>
-            <a:r>
-              <a:t>运动内衣支撑 10%</a:t>
+              <a:rPr dirty="0"/>
+              <a:t>【</a:t>
+            </a:r>
+            <a:r>
+              <a:rPr dirty="0" err="1"/>
+              <a:t>图表占位</a:t>
+            </a:r>
+            <a:r>
+              <a:rPr dirty="0"/>
+              <a:t>】</a:t>
+            </a:r>
+            <a:br>
+              <a:rPr dirty="0"/>
+            </a:br>
+            <a:br>
+              <a:rPr dirty="0"/>
+            </a:br>
+            <a:r>
+              <a:rPr dirty="0" err="1"/>
+              <a:t>尺码不一致</a:t>
+            </a:r>
+            <a:r>
+              <a:rPr dirty="0"/>
+              <a:t> 30% | </a:t>
+            </a:r>
+            <a:r>
+              <a:rPr dirty="0" err="1"/>
+              <a:t>面料耐用性</a:t>
+            </a:r>
+            <a:r>
+              <a:rPr dirty="0"/>
+              <a:t> 25%</a:t>
+            </a:r>
+            <a:br>
+              <a:rPr dirty="0"/>
+            </a:br>
+            <a:r>
+              <a:rPr dirty="0" err="1"/>
+              <a:t>客服售后</a:t>
+            </a:r>
+            <a:r>
+              <a:rPr dirty="0"/>
+              <a:t> 20% | </a:t>
+            </a:r>
+            <a:r>
+              <a:rPr dirty="0" err="1"/>
+              <a:t>限量发售</a:t>
+            </a:r>
+            <a:r>
+              <a:rPr dirty="0"/>
+              <a:t>/APP 15%</a:t>
+            </a:r>
+            <a:br>
+              <a:rPr dirty="0"/>
+            </a:br>
+            <a:r>
+              <a:rPr dirty="0" err="1"/>
+              <a:t>运动内衣支撑</a:t>
+            </a:r>
+            <a:r>
+              <a:rPr dirty="0"/>
+              <a:t> 10%</a:t>
             </a:r>
           </a:p>
         </p:txBody>
@@ -5005,9 +5163,27 @@
                 <a:tableStyleId>{5C22544A-7EE6-4342-B048-85BDC9FD1C3A}</a:tableStyleId>
               </a:tblPr>
               <a:tblGrid>
-                <a:gridCol w="1889760"/>
-                <a:gridCol w="1889760"/>
-                <a:gridCol w="1889760"/>
+                <a:gridCol w="1889760">
+                  <a:extLst>
+                    <a:ext uri="{9D8B030D-6E8A-4147-A177-3AD203B41FA5}">
+                      <a16:colId xmlns:a16="http://schemas.microsoft.com/office/drawing/2014/main" val="20000"/>
+                    </a:ext>
+                  </a:extLst>
+                </a:gridCol>
+                <a:gridCol w="1889760">
+                  <a:extLst>
+                    <a:ext uri="{9D8B030D-6E8A-4147-A177-3AD203B41FA5}">
+                      <a16:colId xmlns:a16="http://schemas.microsoft.com/office/drawing/2014/main" val="20001"/>
+                    </a:ext>
+                  </a:extLst>
+                </a:gridCol>
+                <a:gridCol w="1889760">
+                  <a:extLst>
+                    <a:ext uri="{9D8B030D-6E8A-4147-A177-3AD203B41FA5}">
+                      <a16:colId xmlns:a16="http://schemas.microsoft.com/office/drawing/2014/main" val="20002"/>
+                    </a:ext>
+                  </a:extLst>
+                </a:gridCol>
               </a:tblGrid>
               <a:tr h="487680">
                 <a:tc>
@@ -5082,6 +5258,11 @@
                     </a:solidFill>
                   </a:tcPr>
                 </a:tc>
+                <a:extLst>
+                  <a:ext uri="{0D108BD9-81ED-4DB2-BD59-A6C34878D82A}">
+                    <a16:rowId xmlns:a16="http://schemas.microsoft.com/office/drawing/2014/main" val="10000"/>
+                  </a:ext>
+                </a:extLst>
               </a:tr>
               <a:tr h="487680">
                 <a:tc>
@@ -5144,6 +5325,11 @@
                   </a:txBody>
                   <a:tcPr/>
                 </a:tc>
+                <a:extLst>
+                  <a:ext uri="{0D108BD9-81ED-4DB2-BD59-A6C34878D82A}">
+                    <a16:rowId xmlns:a16="http://schemas.microsoft.com/office/drawing/2014/main" val="10001"/>
+                  </a:ext>
+                </a:extLst>
               </a:tr>
               <a:tr h="487680">
                 <a:tc>
@@ -5218,6 +5404,11 @@
                     </a:solidFill>
                   </a:tcPr>
                 </a:tc>
+                <a:extLst>
+                  <a:ext uri="{0D108BD9-81ED-4DB2-BD59-A6C34878D82A}">
+                    <a16:rowId xmlns:a16="http://schemas.microsoft.com/office/drawing/2014/main" val="10002"/>
+                  </a:ext>
+                </a:extLst>
               </a:tr>
               <a:tr h="487680">
                 <a:tc>
@@ -5280,6 +5471,11 @@
                   </a:txBody>
                   <a:tcPr/>
                 </a:tc>
+                <a:extLst>
+                  <a:ext uri="{0D108BD9-81ED-4DB2-BD59-A6C34878D82A}">
+                    <a16:rowId xmlns:a16="http://schemas.microsoft.com/office/drawing/2014/main" val="10003"/>
+                  </a:ext>
+                </a:extLst>
               </a:tr>
               <a:tr h="487680">
                 <a:tc>
@@ -5354,6 +5550,11 @@
                     </a:solidFill>
                   </a:tcPr>
                 </a:tc>
+                <a:extLst>
+                  <a:ext uri="{0D108BD9-81ED-4DB2-BD59-A6C34878D82A}">
+                    <a16:rowId xmlns:a16="http://schemas.microsoft.com/office/drawing/2014/main" val="10004"/>
+                  </a:ext>
+                </a:extLst>
               </a:tr>
               <a:tr h="487680">
                 <a:tc>
@@ -5416,6 +5617,11 @@
                   </a:txBody>
                   <a:tcPr/>
                 </a:tc>
+                <a:extLst>
+                  <a:ext uri="{0D108BD9-81ED-4DB2-BD59-A6C34878D82A}">
+                    <a16:rowId xmlns:a16="http://schemas.microsoft.com/office/drawing/2014/main" val="10005"/>
+                  </a:ext>
+                </a:extLst>
               </a:tr>
             </a:tbl>
           </a:graphicData>
@@ -5572,8 +5778,8 @@
         </p:blipFill>
         <p:spPr>
           <a:xfrm>
-            <a:off x="365760" y="1645920"/>
-            <a:ext cx="5303520" cy="5222781"/>
+            <a:off x="2924729" y="2094353"/>
+            <a:ext cx="2515951" cy="2477648"/>
           </a:xfrm>
           <a:prstGeom prst="rect">
             <a:avLst/>
@@ -5589,7 +5795,7 @@
 </file>
 
 <file path=ppt/slides/slide12.xml><?xml version="1.0" encoding="utf-8"?>
-<p:sld xmlns:a="http://schemas.openxmlformats.org/drawingml/2006/main" xmlns:p="http://schemas.openxmlformats.org/presentationml/2006/main" xmlns:r="http://schemas.openxmlformats.org/officeDocument/2006/relationships">
+<p:sld xmlns:a="http://schemas.openxmlformats.org/drawingml/2006/main" xmlns:r="http://schemas.openxmlformats.org/officeDocument/2006/relationships" xmlns:p="http://schemas.openxmlformats.org/presentationml/2006/main">
   <p:cSld>
     <p:bg>
       <p:bgPr>
@@ -5605,7 +5811,14 @@
         <p:cNvGrpSpPr/>
         <p:nvPr/>
       </p:nvGrpSpPr>
-      <p:grpSpPr/>
+      <p:grpSpPr>
+        <a:xfrm>
+          <a:off x="0" y="0"/>
+          <a:ext cx="0" cy="0"/>
+          <a:chOff x="0" y="0"/>
+          <a:chExt cx="0" cy="0"/>
+        </a:xfrm>
+      </p:grpSpPr>
       <p:sp>
         <p:nvSpPr>
           <p:cNvPr id="2" name="Rectangle 1"/>
@@ -5646,6 +5859,7 @@
           <a:lstStyle/>
           <a:p>
             <a:pPr algn="ctr"/>
+            <a:endParaRPr/>
           </a:p>
         </p:txBody>
       </p:sp>
@@ -6090,6 +6304,7 @@
           <a:lstStyle/>
           <a:p>
             <a:pPr algn="ctr"/>
+            <a:endParaRPr/>
           </a:p>
         </p:txBody>
       </p:sp>
@@ -6218,7 +6433,7 @@
 </file>
 
 <file path=ppt/slides/slide2.xml><?xml version="1.0" encoding="utf-8"?>
-<p:sld xmlns:a="http://schemas.openxmlformats.org/drawingml/2006/main" xmlns:p="http://schemas.openxmlformats.org/presentationml/2006/main" xmlns:r="http://schemas.openxmlformats.org/officeDocument/2006/relationships">
+<p:sld xmlns:a="http://schemas.openxmlformats.org/drawingml/2006/main" xmlns:r="http://schemas.openxmlformats.org/officeDocument/2006/relationships" xmlns:p="http://schemas.openxmlformats.org/presentationml/2006/main">
   <p:cSld>
     <p:bg>
       <p:bgPr>
@@ -6234,7 +6449,14 @@
         <p:cNvGrpSpPr/>
         <p:nvPr/>
       </p:nvGrpSpPr>
-      <p:grpSpPr/>
+      <p:grpSpPr>
+        <a:xfrm>
+          <a:off x="0" y="0"/>
+          <a:ext cx="0" cy="0"/>
+          <a:chOff x="0" y="0"/>
+          <a:chExt cx="0" cy="0"/>
+        </a:xfrm>
+      </p:grpSpPr>
       <p:sp>
         <p:nvSpPr>
           <p:cNvPr id="2" name="Rectangle 1"/>
@@ -6275,6 +6497,7 @@
           <a:lstStyle/>
           <a:p>
             <a:pPr algn="ctr"/>
+            <a:endParaRPr/>
           </a:p>
         </p:txBody>
       </p:sp>
@@ -6540,9 +6763,27 @@
                 <a:tableStyleId>{5C22544A-7EE6-4342-B048-85BDC9FD1C3A}</a:tableStyleId>
               </a:tblPr>
               <a:tblGrid>
-                <a:gridCol w="1676400"/>
-                <a:gridCol w="1676400"/>
-                <a:gridCol w="1676400"/>
+                <a:gridCol w="1676400">
+                  <a:extLst>
+                    <a:ext uri="{9D8B030D-6E8A-4147-A177-3AD203B41FA5}">
+                      <a16:colId xmlns:a16="http://schemas.microsoft.com/office/drawing/2014/main" val="20000"/>
+                    </a:ext>
+                  </a:extLst>
+                </a:gridCol>
+                <a:gridCol w="1676400">
+                  <a:extLst>
+                    <a:ext uri="{9D8B030D-6E8A-4147-A177-3AD203B41FA5}">
+                      <a16:colId xmlns:a16="http://schemas.microsoft.com/office/drawing/2014/main" val="20001"/>
+                    </a:ext>
+                  </a:extLst>
+                </a:gridCol>
+                <a:gridCol w="1676400">
+                  <a:extLst>
+                    <a:ext uri="{9D8B030D-6E8A-4147-A177-3AD203B41FA5}">
+                      <a16:colId xmlns:a16="http://schemas.microsoft.com/office/drawing/2014/main" val="20002"/>
+                    </a:ext>
+                  </a:extLst>
+                </a:gridCol>
               </a:tblGrid>
               <a:tr h="411480">
                 <a:tc>
@@ -6617,6 +6858,11 @@
                     </a:solidFill>
                   </a:tcPr>
                 </a:tc>
+                <a:extLst>
+                  <a:ext uri="{0D108BD9-81ED-4DB2-BD59-A6C34878D82A}">
+                    <a16:rowId xmlns:a16="http://schemas.microsoft.com/office/drawing/2014/main" val="10000"/>
+                  </a:ext>
+                </a:extLst>
               </a:tr>
               <a:tr h="411480">
                 <a:tc>
@@ -6679,6 +6925,11 @@
                   </a:txBody>
                   <a:tcPr/>
                 </a:tc>
+                <a:extLst>
+                  <a:ext uri="{0D108BD9-81ED-4DB2-BD59-A6C34878D82A}">
+                    <a16:rowId xmlns:a16="http://schemas.microsoft.com/office/drawing/2014/main" val="10001"/>
+                  </a:ext>
+                </a:extLst>
               </a:tr>
               <a:tr h="411480">
                 <a:tc>
@@ -6753,6 +7004,11 @@
                     </a:solidFill>
                   </a:tcPr>
                 </a:tc>
+                <a:extLst>
+                  <a:ext uri="{0D108BD9-81ED-4DB2-BD59-A6C34878D82A}">
+                    <a16:rowId xmlns:a16="http://schemas.microsoft.com/office/drawing/2014/main" val="10002"/>
+                  </a:ext>
+                </a:extLst>
               </a:tr>
               <a:tr h="411480">
                 <a:tc>
@@ -6815,6 +7071,11 @@
                   </a:txBody>
                   <a:tcPr/>
                 </a:tc>
+                <a:extLst>
+                  <a:ext uri="{0D108BD9-81ED-4DB2-BD59-A6C34878D82A}">
+                    <a16:rowId xmlns:a16="http://schemas.microsoft.com/office/drawing/2014/main" val="10003"/>
+                  </a:ext>
+                </a:extLst>
               </a:tr>
             </a:tbl>
           </a:graphicData>
@@ -6962,7 +7223,7 @@
 </file>
 
 <file path=ppt/slides/slide3.xml><?xml version="1.0" encoding="utf-8"?>
-<p:sld xmlns:a="http://schemas.openxmlformats.org/drawingml/2006/main" xmlns:p="http://schemas.openxmlformats.org/presentationml/2006/main" xmlns:r="http://schemas.openxmlformats.org/officeDocument/2006/relationships">
+<p:sld xmlns:a="http://schemas.openxmlformats.org/drawingml/2006/main" xmlns:r="http://schemas.openxmlformats.org/officeDocument/2006/relationships" xmlns:p="http://schemas.openxmlformats.org/presentationml/2006/main">
   <p:cSld>
     <p:bg>
       <p:bgPr>
@@ -6978,7 +7239,14 @@
         <p:cNvGrpSpPr/>
         <p:nvPr/>
       </p:nvGrpSpPr>
-      <p:grpSpPr/>
+      <p:grpSpPr>
+        <a:xfrm>
+          <a:off x="0" y="0"/>
+          <a:ext cx="0" cy="0"/>
+          <a:chOff x="0" y="0"/>
+          <a:chExt cx="0" cy="0"/>
+        </a:xfrm>
+      </p:grpSpPr>
       <p:sp>
         <p:nvSpPr>
           <p:cNvPr id="2" name="Rectangle 1"/>
@@ -7019,6 +7287,7 @@
           <a:lstStyle/>
           <a:p>
             <a:pPr algn="ctr"/>
+            <a:endParaRPr/>
           </a:p>
         </p:txBody>
       </p:sp>
@@ -7113,9 +7382,27 @@
                 <a:tableStyleId>{5C22544A-7EE6-4342-B048-85BDC9FD1C3A}</a:tableStyleId>
               </a:tblPr>
               <a:tblGrid>
-                <a:gridCol w="3657600"/>
-                <a:gridCol w="3657600"/>
-                <a:gridCol w="3657600"/>
+                <a:gridCol w="3657600">
+                  <a:extLst>
+                    <a:ext uri="{9D8B030D-6E8A-4147-A177-3AD203B41FA5}">
+                      <a16:colId xmlns:a16="http://schemas.microsoft.com/office/drawing/2014/main" val="20000"/>
+                    </a:ext>
+                  </a:extLst>
+                </a:gridCol>
+                <a:gridCol w="3657600">
+                  <a:extLst>
+                    <a:ext uri="{9D8B030D-6E8A-4147-A177-3AD203B41FA5}">
+                      <a16:colId xmlns:a16="http://schemas.microsoft.com/office/drawing/2014/main" val="20001"/>
+                    </a:ext>
+                  </a:extLst>
+                </a:gridCol>
+                <a:gridCol w="3657600">
+                  <a:extLst>
+                    <a:ext uri="{9D8B030D-6E8A-4147-A177-3AD203B41FA5}">
+                      <a16:colId xmlns:a16="http://schemas.microsoft.com/office/drawing/2014/main" val="20002"/>
+                    </a:ext>
+                  </a:extLst>
+                </a:gridCol>
               </a:tblGrid>
               <a:tr h="457200">
                 <a:tc>
@@ -7190,6 +7477,11 @@
                     </a:solidFill>
                   </a:tcPr>
                 </a:tc>
+                <a:extLst>
+                  <a:ext uri="{0D108BD9-81ED-4DB2-BD59-A6C34878D82A}">
+                    <a16:rowId xmlns:a16="http://schemas.microsoft.com/office/drawing/2014/main" val="10000"/>
+                  </a:ext>
+                </a:extLst>
               </a:tr>
               <a:tr h="457200">
                 <a:tc>
@@ -7252,6 +7544,11 @@
                   </a:txBody>
                   <a:tcPr/>
                 </a:tc>
+                <a:extLst>
+                  <a:ext uri="{0D108BD9-81ED-4DB2-BD59-A6C34878D82A}">
+                    <a16:rowId xmlns:a16="http://schemas.microsoft.com/office/drawing/2014/main" val="10001"/>
+                  </a:ext>
+                </a:extLst>
               </a:tr>
               <a:tr h="457200">
                 <a:tc>
@@ -7326,6 +7623,11 @@
                     </a:solidFill>
                   </a:tcPr>
                 </a:tc>
+                <a:extLst>
+                  <a:ext uri="{0D108BD9-81ED-4DB2-BD59-A6C34878D82A}">
+                    <a16:rowId xmlns:a16="http://schemas.microsoft.com/office/drawing/2014/main" val="10002"/>
+                  </a:ext>
+                </a:extLst>
               </a:tr>
               <a:tr h="457200">
                 <a:tc>
@@ -7388,6 +7690,11 @@
                   </a:txBody>
                   <a:tcPr/>
                 </a:tc>
+                <a:extLst>
+                  <a:ext uri="{0D108BD9-81ED-4DB2-BD59-A6C34878D82A}">
+                    <a16:rowId xmlns:a16="http://schemas.microsoft.com/office/drawing/2014/main" val="10003"/>
+                  </a:ext>
+                </a:extLst>
               </a:tr>
               <a:tr h="457200">
                 <a:tc>
@@ -7462,6 +7769,11 @@
                     </a:solidFill>
                   </a:tcPr>
                 </a:tc>
+                <a:extLst>
+                  <a:ext uri="{0D108BD9-81ED-4DB2-BD59-A6C34878D82A}">
+                    <a16:rowId xmlns:a16="http://schemas.microsoft.com/office/drawing/2014/main" val="10004"/>
+                  </a:ext>
+                </a:extLst>
               </a:tr>
               <a:tr h="457200">
                 <a:tc>
@@ -7524,6 +7836,11 @@
                   </a:txBody>
                   <a:tcPr/>
                 </a:tc>
+                <a:extLst>
+                  <a:ext uri="{0D108BD9-81ED-4DB2-BD59-A6C34878D82A}">
+                    <a16:rowId xmlns:a16="http://schemas.microsoft.com/office/drawing/2014/main" val="10005"/>
+                  </a:ext>
+                </a:extLst>
               </a:tr>
               <a:tr h="457200">
                 <a:tc>
@@ -7598,6 +7915,11 @@
                     </a:solidFill>
                   </a:tcPr>
                 </a:tc>
+                <a:extLst>
+                  <a:ext uri="{0D108BD9-81ED-4DB2-BD59-A6C34878D82A}">
+                    <a16:rowId xmlns:a16="http://schemas.microsoft.com/office/drawing/2014/main" val="10006"/>
+                  </a:ext>
+                </a:extLst>
               </a:tr>
               <a:tr h="457200">
                 <a:tc>
@@ -7660,6 +7982,11 @@
                   </a:txBody>
                   <a:tcPr/>
                 </a:tc>
+                <a:extLst>
+                  <a:ext uri="{0D108BD9-81ED-4DB2-BD59-A6C34878D82A}">
+                    <a16:rowId xmlns:a16="http://schemas.microsoft.com/office/drawing/2014/main" val="10007"/>
+                  </a:ext>
+                </a:extLst>
               </a:tr>
               <a:tr h="457200">
                 <a:tc>
@@ -7734,6 +8061,11 @@
                     </a:solidFill>
                   </a:tcPr>
                 </a:tc>
+                <a:extLst>
+                  <a:ext uri="{0D108BD9-81ED-4DB2-BD59-A6C34878D82A}">
+                    <a16:rowId xmlns:a16="http://schemas.microsoft.com/office/drawing/2014/main" val="10008"/>
+                  </a:ext>
+                </a:extLst>
               </a:tr>
             </a:tbl>
           </a:graphicData>
@@ -7826,7 +8158,7 @@
 </file>
 
 <file path=ppt/slides/slide4.xml><?xml version="1.0" encoding="utf-8"?>
-<p:sld xmlns:a="http://schemas.openxmlformats.org/drawingml/2006/main" xmlns:p="http://schemas.openxmlformats.org/presentationml/2006/main" xmlns:r="http://schemas.openxmlformats.org/officeDocument/2006/relationships">
+<p:sld xmlns:a="http://schemas.openxmlformats.org/drawingml/2006/main" xmlns:r="http://schemas.openxmlformats.org/officeDocument/2006/relationships" xmlns:p="http://schemas.openxmlformats.org/presentationml/2006/main">
   <p:cSld>
     <p:bg>
       <p:bgPr>
@@ -7842,7 +8174,14 @@
         <p:cNvGrpSpPr/>
         <p:nvPr/>
       </p:nvGrpSpPr>
-      <p:grpSpPr/>
+      <p:grpSpPr>
+        <a:xfrm>
+          <a:off x="0" y="0"/>
+          <a:ext cx="0" cy="0"/>
+          <a:chOff x="0" y="0"/>
+          <a:chExt cx="0" cy="0"/>
+        </a:xfrm>
+      </p:grpSpPr>
       <p:sp>
         <p:nvSpPr>
           <p:cNvPr id="2" name="Rectangle 1"/>
@@ -7883,6 +8222,7 @@
           <a:lstStyle/>
           <a:p>
             <a:pPr algn="ctr"/>
+            <a:endParaRPr/>
           </a:p>
         </p:txBody>
       </p:sp>
@@ -7977,10 +8317,34 @@
                 <a:tableStyleId>{5C22544A-7EE6-4342-B048-85BDC9FD1C3A}</a:tableStyleId>
               </a:tblPr>
               <a:tblGrid>
-                <a:gridCol w="1714500"/>
-                <a:gridCol w="1714500"/>
-                <a:gridCol w="1714500"/>
-                <a:gridCol w="1714500"/>
+                <a:gridCol w="1714500">
+                  <a:extLst>
+                    <a:ext uri="{9D8B030D-6E8A-4147-A177-3AD203B41FA5}">
+                      <a16:colId xmlns:a16="http://schemas.microsoft.com/office/drawing/2014/main" val="20000"/>
+                    </a:ext>
+                  </a:extLst>
+                </a:gridCol>
+                <a:gridCol w="1714500">
+                  <a:extLst>
+                    <a:ext uri="{9D8B030D-6E8A-4147-A177-3AD203B41FA5}">
+                      <a16:colId xmlns:a16="http://schemas.microsoft.com/office/drawing/2014/main" val="20001"/>
+                    </a:ext>
+                  </a:extLst>
+                </a:gridCol>
+                <a:gridCol w="1714500">
+                  <a:extLst>
+                    <a:ext uri="{9D8B030D-6E8A-4147-A177-3AD203B41FA5}">
+                      <a16:colId xmlns:a16="http://schemas.microsoft.com/office/drawing/2014/main" val="20002"/>
+                    </a:ext>
+                  </a:extLst>
+                </a:gridCol>
+                <a:gridCol w="1714500">
+                  <a:extLst>
+                    <a:ext uri="{9D8B030D-6E8A-4147-A177-3AD203B41FA5}">
+                      <a16:colId xmlns:a16="http://schemas.microsoft.com/office/drawing/2014/main" val="20003"/>
+                    </a:ext>
+                  </a:extLst>
+                </a:gridCol>
               </a:tblGrid>
               <a:tr h="480060">
                 <a:tc>
@@ -8079,6 +8443,11 @@
                     </a:solidFill>
                   </a:tcPr>
                 </a:tc>
+                <a:extLst>
+                  <a:ext uri="{0D108BD9-81ED-4DB2-BD59-A6C34878D82A}">
+                    <a16:rowId xmlns:a16="http://schemas.microsoft.com/office/drawing/2014/main" val="10000"/>
+                  </a:ext>
+                </a:extLst>
               </a:tr>
               <a:tr h="480060">
                 <a:tc>
@@ -8161,6 +8530,11 @@
                   </a:txBody>
                   <a:tcPr/>
                 </a:tc>
+                <a:extLst>
+                  <a:ext uri="{0D108BD9-81ED-4DB2-BD59-A6C34878D82A}">
+                    <a16:rowId xmlns:a16="http://schemas.microsoft.com/office/drawing/2014/main" val="10001"/>
+                  </a:ext>
+                </a:extLst>
               </a:tr>
               <a:tr h="480060">
                 <a:tc>
@@ -8259,6 +8633,11 @@
                     </a:solidFill>
                   </a:tcPr>
                 </a:tc>
+                <a:extLst>
+                  <a:ext uri="{0D108BD9-81ED-4DB2-BD59-A6C34878D82A}">
+                    <a16:rowId xmlns:a16="http://schemas.microsoft.com/office/drawing/2014/main" val="10002"/>
+                  </a:ext>
+                </a:extLst>
               </a:tr>
               <a:tr h="480060">
                 <a:tc>
@@ -8341,6 +8720,11 @@
                   </a:txBody>
                   <a:tcPr/>
                 </a:tc>
+                <a:extLst>
+                  <a:ext uri="{0D108BD9-81ED-4DB2-BD59-A6C34878D82A}">
+                    <a16:rowId xmlns:a16="http://schemas.microsoft.com/office/drawing/2014/main" val="10003"/>
+                  </a:ext>
+                </a:extLst>
               </a:tr>
               <a:tr h="480060">
                 <a:tc>
@@ -8439,6 +8823,11 @@
                     </a:solidFill>
                   </a:tcPr>
                 </a:tc>
+                <a:extLst>
+                  <a:ext uri="{0D108BD9-81ED-4DB2-BD59-A6C34878D82A}">
+                    <a16:rowId xmlns:a16="http://schemas.microsoft.com/office/drawing/2014/main" val="10004"/>
+                  </a:ext>
+                </a:extLst>
               </a:tr>
               <a:tr h="480060">
                 <a:tc>
@@ -8521,6 +8910,11 @@
                   </a:txBody>
                   <a:tcPr/>
                 </a:tc>
+                <a:extLst>
+                  <a:ext uri="{0D108BD9-81ED-4DB2-BD59-A6C34878D82A}">
+                    <a16:rowId xmlns:a16="http://schemas.microsoft.com/office/drawing/2014/main" val="10005"/>
+                  </a:ext>
+                </a:extLst>
               </a:tr>
               <a:tr h="480060">
                 <a:tc>
@@ -8619,6 +9013,11 @@
                     </a:solidFill>
                   </a:tcPr>
                 </a:tc>
+                <a:extLst>
+                  <a:ext uri="{0D108BD9-81ED-4DB2-BD59-A6C34878D82A}">
+                    <a16:rowId xmlns:a16="http://schemas.microsoft.com/office/drawing/2014/main" val="10006"/>
+                  </a:ext>
+                </a:extLst>
               </a:tr>
               <a:tr h="480060">
                 <a:tc>
@@ -8701,6 +9100,11 @@
                   </a:txBody>
                   <a:tcPr/>
                 </a:tc>
+                <a:extLst>
+                  <a:ext uri="{0D108BD9-81ED-4DB2-BD59-A6C34878D82A}">
+                    <a16:rowId xmlns:a16="http://schemas.microsoft.com/office/drawing/2014/main" val="10007"/>
+                  </a:ext>
+                </a:extLst>
               </a:tr>
             </a:tbl>
           </a:graphicData>
@@ -8748,6 +9152,7 @@
           <a:lstStyle/>
           <a:p>
             <a:pPr algn="ctr"/>
+            <a:endParaRPr/>
           </a:p>
         </p:txBody>
       </p:sp>
@@ -8795,7 +9200,7 @@
         </p:nvSpPr>
         <p:spPr>
           <a:xfrm>
-            <a:off x="7863840" y="2743200"/>
+            <a:off x="7818120" y="1746259"/>
             <a:ext cx="3657600" cy="1371600"/>
           </a:xfrm>
           <a:prstGeom prst="rect">
@@ -8818,19 +9223,39 @@
               </a:defRPr>
             </a:pPr>
             <a:r>
-              <a:t>【图表占位】</a:t>
-            </a:r>
-            <a:br/>
-            <a:br/>
-            <a:r>
+              <a:rPr dirty="0"/>
+              <a:t>【</a:t>
+            </a:r>
+            <a:r>
+              <a:rPr dirty="0" err="1"/>
+              <a:t>图表占位</a:t>
+            </a:r>
+            <a:r>
+              <a:rPr dirty="0"/>
+              <a:t>】</a:t>
+            </a:r>
+            <a:br>
+              <a:rPr dirty="0"/>
+            </a:br>
+            <a:br>
+              <a:rPr dirty="0"/>
+            </a:br>
+            <a:r>
+              <a:rPr dirty="0"/>
               <a:t>Gymshark：社区文化10 / KOL营销10 / 性价比9</a:t>
             </a:r>
-            <a:br/>
-            <a:r>
+            <a:br>
+              <a:rPr dirty="0"/>
+            </a:br>
+            <a:r>
+              <a:rPr dirty="0"/>
               <a:t>Lululemon：品牌影响力10 / 线下渠道10</a:t>
             </a:r>
-            <a:br/>
-            <a:r>
+            <a:br>
+              <a:rPr dirty="0"/>
+            </a:br>
+            <a:r>
+              <a:rPr dirty="0"/>
               <a:t>Alphalete：KOL营销8，其余维度规模较小</a:t>
             </a:r>
           </a:p>
@@ -8949,8 +9374,8 @@
         </p:blipFill>
         <p:spPr>
           <a:xfrm>
-            <a:off x="7132320" y="1188720"/>
-            <a:ext cx="4572000" cy="3841886"/>
+            <a:off x="8285867" y="2690922"/>
+            <a:ext cx="2722106" cy="2287406"/>
           </a:xfrm>
           <a:prstGeom prst="rect">
             <a:avLst/>
@@ -8966,7 +9391,7 @@
 </file>
 
 <file path=ppt/slides/slide5.xml><?xml version="1.0" encoding="utf-8"?>
-<p:sld xmlns:a="http://schemas.openxmlformats.org/drawingml/2006/main" xmlns:p="http://schemas.openxmlformats.org/presentationml/2006/main" xmlns:r="http://schemas.openxmlformats.org/officeDocument/2006/relationships">
+<p:sld xmlns:a="http://schemas.openxmlformats.org/drawingml/2006/main" xmlns:r="http://schemas.openxmlformats.org/officeDocument/2006/relationships" xmlns:p="http://schemas.openxmlformats.org/presentationml/2006/main">
   <p:cSld>
     <p:bg>
       <p:bgPr>
@@ -8982,7 +9407,14 @@
         <p:cNvGrpSpPr/>
         <p:nvPr/>
       </p:nvGrpSpPr>
-      <p:grpSpPr/>
+      <p:grpSpPr>
+        <a:xfrm>
+          <a:off x="0" y="0"/>
+          <a:ext cx="0" cy="0"/>
+          <a:chOff x="0" y="0"/>
+          <a:chExt cx="0" cy="0"/>
+        </a:xfrm>
+      </p:grpSpPr>
       <p:sp>
         <p:nvSpPr>
           <p:cNvPr id="2" name="Rectangle 1"/>
@@ -9023,6 +9455,7 @@
           <a:lstStyle/>
           <a:p>
             <a:pPr algn="ctr"/>
+            <a:endParaRPr/>
           </a:p>
         </p:txBody>
       </p:sp>
@@ -9117,10 +9550,34 @@
                 <a:tableStyleId>{5C22544A-7EE6-4342-B048-85BDC9FD1C3A}</a:tableStyleId>
               </a:tblPr>
               <a:tblGrid>
-                <a:gridCol w="1485900"/>
-                <a:gridCol w="1485900"/>
-                <a:gridCol w="1485900"/>
-                <a:gridCol w="1485900"/>
+                <a:gridCol w="1485900">
+                  <a:extLst>
+                    <a:ext uri="{9D8B030D-6E8A-4147-A177-3AD203B41FA5}">
+                      <a16:colId xmlns:a16="http://schemas.microsoft.com/office/drawing/2014/main" val="20000"/>
+                    </a:ext>
+                  </a:extLst>
+                </a:gridCol>
+                <a:gridCol w="1485900">
+                  <a:extLst>
+                    <a:ext uri="{9D8B030D-6E8A-4147-A177-3AD203B41FA5}">
+                      <a16:colId xmlns:a16="http://schemas.microsoft.com/office/drawing/2014/main" val="20001"/>
+                    </a:ext>
+                  </a:extLst>
+                </a:gridCol>
+                <a:gridCol w="1485900">
+                  <a:extLst>
+                    <a:ext uri="{9D8B030D-6E8A-4147-A177-3AD203B41FA5}">
+                      <a16:colId xmlns:a16="http://schemas.microsoft.com/office/drawing/2014/main" val="20002"/>
+                    </a:ext>
+                  </a:extLst>
+                </a:gridCol>
+                <a:gridCol w="1485900">
+                  <a:extLst>
+                    <a:ext uri="{9D8B030D-6E8A-4147-A177-3AD203B41FA5}">
+                      <a16:colId xmlns:a16="http://schemas.microsoft.com/office/drawing/2014/main" val="20003"/>
+                    </a:ext>
+                  </a:extLst>
+                </a:gridCol>
               </a:tblGrid>
               <a:tr h="496388">
                 <a:tc>
@@ -9219,6 +9676,11 @@
                     </a:solidFill>
                   </a:tcPr>
                 </a:tc>
+                <a:extLst>
+                  <a:ext uri="{0D108BD9-81ED-4DB2-BD59-A6C34878D82A}">
+                    <a16:rowId xmlns:a16="http://schemas.microsoft.com/office/drawing/2014/main" val="10000"/>
+                  </a:ext>
+                </a:extLst>
               </a:tr>
               <a:tr h="496388">
                 <a:tc>
@@ -9301,6 +9763,11 @@
                   </a:txBody>
                   <a:tcPr/>
                 </a:tc>
+                <a:extLst>
+                  <a:ext uri="{0D108BD9-81ED-4DB2-BD59-A6C34878D82A}">
+                    <a16:rowId xmlns:a16="http://schemas.microsoft.com/office/drawing/2014/main" val="10001"/>
+                  </a:ext>
+                </a:extLst>
               </a:tr>
               <a:tr h="496388">
                 <a:tc>
@@ -9399,6 +9866,11 @@
                     </a:solidFill>
                   </a:tcPr>
                 </a:tc>
+                <a:extLst>
+                  <a:ext uri="{0D108BD9-81ED-4DB2-BD59-A6C34878D82A}">
+                    <a16:rowId xmlns:a16="http://schemas.microsoft.com/office/drawing/2014/main" val="10002"/>
+                  </a:ext>
+                </a:extLst>
               </a:tr>
               <a:tr h="496388">
                 <a:tc>
@@ -9481,6 +9953,11 @@
                   </a:txBody>
                   <a:tcPr/>
                 </a:tc>
+                <a:extLst>
+                  <a:ext uri="{0D108BD9-81ED-4DB2-BD59-A6C34878D82A}">
+                    <a16:rowId xmlns:a16="http://schemas.microsoft.com/office/drawing/2014/main" val="10003"/>
+                  </a:ext>
+                </a:extLst>
               </a:tr>
               <a:tr h="496388">
                 <a:tc>
@@ -9579,6 +10056,11 @@
                     </a:solidFill>
                   </a:tcPr>
                 </a:tc>
+                <a:extLst>
+                  <a:ext uri="{0D108BD9-81ED-4DB2-BD59-A6C34878D82A}">
+                    <a16:rowId xmlns:a16="http://schemas.microsoft.com/office/drawing/2014/main" val="10004"/>
+                  </a:ext>
+                </a:extLst>
               </a:tr>
               <a:tr h="496388">
                 <a:tc>
@@ -9661,6 +10143,11 @@
                   </a:txBody>
                   <a:tcPr/>
                 </a:tc>
+                <a:extLst>
+                  <a:ext uri="{0D108BD9-81ED-4DB2-BD59-A6C34878D82A}">
+                    <a16:rowId xmlns:a16="http://schemas.microsoft.com/office/drawing/2014/main" val="10005"/>
+                  </a:ext>
+                </a:extLst>
               </a:tr>
               <a:tr h="496392">
                 <a:tc>
@@ -9759,6 +10246,11 @@
                     </a:solidFill>
                   </a:tcPr>
                 </a:tc>
+                <a:extLst>
+                  <a:ext uri="{0D108BD9-81ED-4DB2-BD59-A6C34878D82A}">
+                    <a16:rowId xmlns:a16="http://schemas.microsoft.com/office/drawing/2014/main" val="10006"/>
+                  </a:ext>
+                </a:extLst>
               </a:tr>
             </a:tbl>
           </a:graphicData>
@@ -9773,7 +10265,7 @@
         <p:spPr>
           <a:xfrm>
             <a:off x="6766560" y="1280160"/>
-            <a:ext cx="4846320" cy="3474720"/>
+            <a:ext cx="4846320" cy="5394960"/>
           </a:xfrm>
           <a:prstGeom prst="roundRect">
             <a:avLst/>
@@ -9806,6 +10298,7 @@
           <a:lstStyle/>
           <a:p>
             <a:pPr algn="ctr"/>
+            <a:endParaRPr/>
           </a:p>
         </p:txBody>
       </p:sp>
@@ -9853,7 +10346,7 @@
         </p:nvSpPr>
         <p:spPr>
           <a:xfrm>
-            <a:off x="6949440" y="2743200"/>
+            <a:off x="6903720" y="1920240"/>
             <a:ext cx="4572000" cy="1371600"/>
           </a:xfrm>
           <a:prstGeom prst="rect">
@@ -9876,19 +10369,39 @@
               </a:defRPr>
             </a:pPr>
             <a:r>
-              <a:t>【图表占位】</a:t>
-            </a:r>
-            <a:br/>
-            <a:br/>
-            <a:r>
+              <a:rPr dirty="0"/>
+              <a:t>【</a:t>
+            </a:r>
+            <a:r>
+              <a:rPr dirty="0" err="1"/>
+              <a:t>图表占位</a:t>
+            </a:r>
+            <a:r>
+              <a:rPr dirty="0"/>
+              <a:t>】</a:t>
+            </a:r>
+            <a:br>
+              <a:rPr dirty="0"/>
+            </a:br>
+            <a:br>
+              <a:rPr dirty="0"/>
+            </a:br>
+            <a:r>
+              <a:rPr dirty="0" err="1"/>
               <a:t>Gymshark全品类价格三家最低</a:t>
             </a:r>
-            <a:br/>
-            <a:r>
+            <a:br>
+              <a:rPr dirty="0"/>
+            </a:br>
+            <a:r>
+              <a:rPr dirty="0"/>
               <a:t>Leggings比Lululemon低约46%</a:t>
             </a:r>
-            <a:br/>
-            <a:r>
+            <a:br>
+              <a:rPr dirty="0"/>
+            </a:br>
+            <a:r>
+              <a:rPr dirty="0"/>
               <a:t>精准卡位$40-80中端价格带</a:t>
             </a:r>
           </a:p>
@@ -10045,8 +10558,8 @@
         </p:blipFill>
         <p:spPr>
           <a:xfrm>
-            <a:off x="6217920" y="1188720"/>
-            <a:ext cx="5486400" cy="3267472"/>
+            <a:off x="7363096" y="3291840"/>
+            <a:ext cx="3744688" cy="2230181"/>
           </a:xfrm>
           <a:prstGeom prst="rect">
             <a:avLst/>
@@ -10062,7 +10575,7 @@
 </file>
 
 <file path=ppt/slides/slide6.xml><?xml version="1.0" encoding="utf-8"?>
-<p:sld xmlns:a="http://schemas.openxmlformats.org/drawingml/2006/main" xmlns:p="http://schemas.openxmlformats.org/presentationml/2006/main" xmlns:r="http://schemas.openxmlformats.org/officeDocument/2006/relationships">
+<p:sld xmlns:a="http://schemas.openxmlformats.org/drawingml/2006/main" xmlns:r="http://schemas.openxmlformats.org/officeDocument/2006/relationships" xmlns:p="http://schemas.openxmlformats.org/presentationml/2006/main">
   <p:cSld>
     <p:bg>
       <p:bgPr>
@@ -10078,7 +10591,14 @@
         <p:cNvGrpSpPr/>
         <p:nvPr/>
       </p:nvGrpSpPr>
-      <p:grpSpPr/>
+      <p:grpSpPr>
+        <a:xfrm>
+          <a:off x="0" y="0"/>
+          <a:ext cx="0" cy="0"/>
+          <a:chOff x="0" y="0"/>
+          <a:chExt cx="0" cy="0"/>
+        </a:xfrm>
+      </p:grpSpPr>
       <p:sp>
         <p:nvSpPr>
           <p:cNvPr id="2" name="Rectangle 1"/>
@@ -10119,6 +10639,7 @@
           <a:lstStyle/>
           <a:p>
             <a:pPr algn="ctr"/>
+            <a:endParaRPr/>
           </a:p>
         </p:txBody>
       </p:sp>
@@ -10213,10 +10734,34 @@
                 <a:tableStyleId>{5C22544A-7EE6-4342-B048-85BDC9FD1C3A}</a:tableStyleId>
               </a:tblPr>
               <a:tblGrid>
-                <a:gridCol w="2743200"/>
-                <a:gridCol w="2743200"/>
-                <a:gridCol w="2743200"/>
-                <a:gridCol w="2743200"/>
+                <a:gridCol w="2743200">
+                  <a:extLst>
+                    <a:ext uri="{9D8B030D-6E8A-4147-A177-3AD203B41FA5}">
+                      <a16:colId xmlns:a16="http://schemas.microsoft.com/office/drawing/2014/main" val="20000"/>
+                    </a:ext>
+                  </a:extLst>
+                </a:gridCol>
+                <a:gridCol w="2743200">
+                  <a:extLst>
+                    <a:ext uri="{9D8B030D-6E8A-4147-A177-3AD203B41FA5}">
+                      <a16:colId xmlns:a16="http://schemas.microsoft.com/office/drawing/2014/main" val="20001"/>
+                    </a:ext>
+                  </a:extLst>
+                </a:gridCol>
+                <a:gridCol w="2743200">
+                  <a:extLst>
+                    <a:ext uri="{9D8B030D-6E8A-4147-A177-3AD203B41FA5}">
+                      <a16:colId xmlns:a16="http://schemas.microsoft.com/office/drawing/2014/main" val="20002"/>
+                    </a:ext>
+                  </a:extLst>
+                </a:gridCol>
+                <a:gridCol w="2743200">
+                  <a:extLst>
+                    <a:ext uri="{9D8B030D-6E8A-4147-A177-3AD203B41FA5}">
+                      <a16:colId xmlns:a16="http://schemas.microsoft.com/office/drawing/2014/main" val="20003"/>
+                    </a:ext>
+                  </a:extLst>
+                </a:gridCol>
               </a:tblGrid>
               <a:tr h="487680">
                 <a:tc>
@@ -10315,6 +10860,11 @@
                     </a:solidFill>
                   </a:tcPr>
                 </a:tc>
+                <a:extLst>
+                  <a:ext uri="{0D108BD9-81ED-4DB2-BD59-A6C34878D82A}">
+                    <a16:rowId xmlns:a16="http://schemas.microsoft.com/office/drawing/2014/main" val="10000"/>
+                  </a:ext>
+                </a:extLst>
               </a:tr>
               <a:tr h="487680">
                 <a:tc>
@@ -10397,6 +10947,11 @@
                   </a:txBody>
                   <a:tcPr/>
                 </a:tc>
+                <a:extLst>
+                  <a:ext uri="{0D108BD9-81ED-4DB2-BD59-A6C34878D82A}">
+                    <a16:rowId xmlns:a16="http://schemas.microsoft.com/office/drawing/2014/main" val="10001"/>
+                  </a:ext>
+                </a:extLst>
               </a:tr>
               <a:tr h="487680">
                 <a:tc>
@@ -10495,6 +11050,11 @@
                     </a:solidFill>
                   </a:tcPr>
                 </a:tc>
+                <a:extLst>
+                  <a:ext uri="{0D108BD9-81ED-4DB2-BD59-A6C34878D82A}">
+                    <a16:rowId xmlns:a16="http://schemas.microsoft.com/office/drawing/2014/main" val="10002"/>
+                  </a:ext>
+                </a:extLst>
               </a:tr>
               <a:tr h="487680">
                 <a:tc>
@@ -10577,6 +11137,11 @@
                   </a:txBody>
                   <a:tcPr/>
                 </a:tc>
+                <a:extLst>
+                  <a:ext uri="{0D108BD9-81ED-4DB2-BD59-A6C34878D82A}">
+                    <a16:rowId xmlns:a16="http://schemas.microsoft.com/office/drawing/2014/main" val="10003"/>
+                  </a:ext>
+                </a:extLst>
               </a:tr>
               <a:tr h="487680">
                 <a:tc>
@@ -10675,6 +11240,11 @@
                     </a:solidFill>
                   </a:tcPr>
                 </a:tc>
+                <a:extLst>
+                  <a:ext uri="{0D108BD9-81ED-4DB2-BD59-A6C34878D82A}">
+                    <a16:rowId xmlns:a16="http://schemas.microsoft.com/office/drawing/2014/main" val="10004"/>
+                  </a:ext>
+                </a:extLst>
               </a:tr>
               <a:tr h="487680">
                 <a:tc>
@@ -10757,6 +11327,11 @@
                   </a:txBody>
                   <a:tcPr/>
                 </a:tc>
+                <a:extLst>
+                  <a:ext uri="{0D108BD9-81ED-4DB2-BD59-A6C34878D82A}">
+                    <a16:rowId xmlns:a16="http://schemas.microsoft.com/office/drawing/2014/main" val="10005"/>
+                  </a:ext>
+                </a:extLst>
               </a:tr>
             </a:tbl>
           </a:graphicData>
@@ -11119,7 +11694,7 @@
 </file>
 
 <file path=ppt/slides/slide7.xml><?xml version="1.0" encoding="utf-8"?>
-<p:sld xmlns:a="http://schemas.openxmlformats.org/drawingml/2006/main" xmlns:p="http://schemas.openxmlformats.org/presentationml/2006/main" xmlns:r="http://schemas.openxmlformats.org/officeDocument/2006/relationships">
+<p:sld xmlns:a="http://schemas.openxmlformats.org/drawingml/2006/main" xmlns:r="http://schemas.openxmlformats.org/officeDocument/2006/relationships" xmlns:p="http://schemas.openxmlformats.org/presentationml/2006/main">
   <p:cSld>
     <p:bg>
       <p:bgPr>
@@ -11135,7 +11710,14 @@
         <p:cNvGrpSpPr/>
         <p:nvPr/>
       </p:nvGrpSpPr>
-      <p:grpSpPr/>
+      <p:grpSpPr>
+        <a:xfrm>
+          <a:off x="0" y="0"/>
+          <a:ext cx="0" cy="0"/>
+          <a:chOff x="0" y="0"/>
+          <a:chExt cx="0" cy="0"/>
+        </a:xfrm>
+      </p:grpSpPr>
       <p:sp>
         <p:nvSpPr>
           <p:cNvPr id="2" name="Rectangle 1"/>
@@ -11176,6 +11758,7 @@
           <a:lstStyle/>
           <a:p>
             <a:pPr algn="ctr"/>
+            <a:endParaRPr/>
           </a:p>
         </p:txBody>
       </p:sp>
@@ -11270,10 +11853,34 @@
                 <a:tableStyleId>{5C22544A-7EE6-4342-B048-85BDC9FD1C3A}</a:tableStyleId>
               </a:tblPr>
               <a:tblGrid>
-                <a:gridCol w="2743200"/>
-                <a:gridCol w="2743200"/>
-                <a:gridCol w="2743200"/>
-                <a:gridCol w="2743200"/>
+                <a:gridCol w="2743200">
+                  <a:extLst>
+                    <a:ext uri="{9D8B030D-6E8A-4147-A177-3AD203B41FA5}">
+                      <a16:colId xmlns:a16="http://schemas.microsoft.com/office/drawing/2014/main" val="20000"/>
+                    </a:ext>
+                  </a:extLst>
+                </a:gridCol>
+                <a:gridCol w="2743200">
+                  <a:extLst>
+                    <a:ext uri="{9D8B030D-6E8A-4147-A177-3AD203B41FA5}">
+                      <a16:colId xmlns:a16="http://schemas.microsoft.com/office/drawing/2014/main" val="20001"/>
+                    </a:ext>
+                  </a:extLst>
+                </a:gridCol>
+                <a:gridCol w="2743200">
+                  <a:extLst>
+                    <a:ext uri="{9D8B030D-6E8A-4147-A177-3AD203B41FA5}">
+                      <a16:colId xmlns:a16="http://schemas.microsoft.com/office/drawing/2014/main" val="20002"/>
+                    </a:ext>
+                  </a:extLst>
+                </a:gridCol>
+                <a:gridCol w="2743200">
+                  <a:extLst>
+                    <a:ext uri="{9D8B030D-6E8A-4147-A177-3AD203B41FA5}">
+                      <a16:colId xmlns:a16="http://schemas.microsoft.com/office/drawing/2014/main" val="20003"/>
+                    </a:ext>
+                  </a:extLst>
+                </a:gridCol>
               </a:tblGrid>
               <a:tr h="426720">
                 <a:tc>
@@ -11372,6 +11979,11 @@
                     </a:solidFill>
                   </a:tcPr>
                 </a:tc>
+                <a:extLst>
+                  <a:ext uri="{0D108BD9-81ED-4DB2-BD59-A6C34878D82A}">
+                    <a16:rowId xmlns:a16="http://schemas.microsoft.com/office/drawing/2014/main" val="10000"/>
+                  </a:ext>
+                </a:extLst>
               </a:tr>
               <a:tr h="426720">
                 <a:tc>
@@ -11454,6 +12066,11 @@
                   </a:txBody>
                   <a:tcPr/>
                 </a:tc>
+                <a:extLst>
+                  <a:ext uri="{0D108BD9-81ED-4DB2-BD59-A6C34878D82A}">
+                    <a16:rowId xmlns:a16="http://schemas.microsoft.com/office/drawing/2014/main" val="10001"/>
+                  </a:ext>
+                </a:extLst>
               </a:tr>
               <a:tr h="426720">
                 <a:tc>
@@ -11552,6 +12169,11 @@
                     </a:solidFill>
                   </a:tcPr>
                 </a:tc>
+                <a:extLst>
+                  <a:ext uri="{0D108BD9-81ED-4DB2-BD59-A6C34878D82A}">
+                    <a16:rowId xmlns:a16="http://schemas.microsoft.com/office/drawing/2014/main" val="10002"/>
+                  </a:ext>
+                </a:extLst>
               </a:tr>
               <a:tr h="426720">
                 <a:tc>
@@ -11634,6 +12256,11 @@
                   </a:txBody>
                   <a:tcPr/>
                 </a:tc>
+                <a:extLst>
+                  <a:ext uri="{0D108BD9-81ED-4DB2-BD59-A6C34878D82A}">
+                    <a16:rowId xmlns:a16="http://schemas.microsoft.com/office/drawing/2014/main" val="10003"/>
+                  </a:ext>
+                </a:extLst>
               </a:tr>
               <a:tr h="426720">
                 <a:tc>
@@ -11732,6 +12359,11 @@
                     </a:solidFill>
                   </a:tcPr>
                 </a:tc>
+                <a:extLst>
+                  <a:ext uri="{0D108BD9-81ED-4DB2-BD59-A6C34878D82A}">
+                    <a16:rowId xmlns:a16="http://schemas.microsoft.com/office/drawing/2014/main" val="10004"/>
+                  </a:ext>
+                </a:extLst>
               </a:tr>
               <a:tr h="426720">
                 <a:tc>
@@ -11814,6 +12446,11 @@
                   </a:txBody>
                   <a:tcPr/>
                 </a:tc>
+                <a:extLst>
+                  <a:ext uri="{0D108BD9-81ED-4DB2-BD59-A6C34878D82A}">
+                    <a16:rowId xmlns:a16="http://schemas.microsoft.com/office/drawing/2014/main" val="10005"/>
+                  </a:ext>
+                </a:extLst>
               </a:tr>
             </a:tbl>
           </a:graphicData>
@@ -11963,7 +12600,7 @@
 </file>
 
 <file path=ppt/slides/slide8.xml><?xml version="1.0" encoding="utf-8"?>
-<p:sld xmlns:a="http://schemas.openxmlformats.org/drawingml/2006/main" xmlns:p="http://schemas.openxmlformats.org/presentationml/2006/main" xmlns:r="http://schemas.openxmlformats.org/officeDocument/2006/relationships">
+<p:sld xmlns:a="http://schemas.openxmlformats.org/drawingml/2006/main" xmlns:r="http://schemas.openxmlformats.org/officeDocument/2006/relationships" xmlns:p="http://schemas.openxmlformats.org/presentationml/2006/main">
   <p:cSld>
     <p:bg>
       <p:bgPr>
@@ -11979,7 +12616,14 @@
         <p:cNvGrpSpPr/>
         <p:nvPr/>
       </p:nvGrpSpPr>
-      <p:grpSpPr/>
+      <p:grpSpPr>
+        <a:xfrm>
+          <a:off x="0" y="0"/>
+          <a:ext cx="0" cy="0"/>
+          <a:chOff x="0" y="0"/>
+          <a:chExt cx="0" cy="0"/>
+        </a:xfrm>
+      </p:grpSpPr>
       <p:sp>
         <p:nvSpPr>
           <p:cNvPr id="2" name="Rectangle 1"/>
@@ -12020,6 +12664,7 @@
           <a:lstStyle/>
           <a:p>
             <a:pPr algn="ctr"/>
+            <a:endParaRPr/>
           </a:p>
         </p:txBody>
       </p:sp>
@@ -12285,8 +12930,20 @@
                 <a:tableStyleId>{5C22544A-7EE6-4342-B048-85BDC9FD1C3A}</a:tableStyleId>
               </a:tblPr>
               <a:tblGrid>
-                <a:gridCol w="2514600"/>
-                <a:gridCol w="2514600"/>
+                <a:gridCol w="2514600">
+                  <a:extLst>
+                    <a:ext uri="{9D8B030D-6E8A-4147-A177-3AD203B41FA5}">
+                      <a16:colId xmlns:a16="http://schemas.microsoft.com/office/drawing/2014/main" val="20000"/>
+                    </a:ext>
+                  </a:extLst>
+                </a:gridCol>
+                <a:gridCol w="2514600">
+                  <a:extLst>
+                    <a:ext uri="{9D8B030D-6E8A-4147-A177-3AD203B41FA5}">
+                      <a16:colId xmlns:a16="http://schemas.microsoft.com/office/drawing/2014/main" val="20001"/>
+                    </a:ext>
+                  </a:extLst>
+                </a:gridCol>
               </a:tblGrid>
               <a:tr h="402336">
                 <a:tc>
@@ -12337,6 +12994,11 @@
                     </a:solidFill>
                   </a:tcPr>
                 </a:tc>
+                <a:extLst>
+                  <a:ext uri="{0D108BD9-81ED-4DB2-BD59-A6C34878D82A}">
+                    <a16:rowId xmlns:a16="http://schemas.microsoft.com/office/drawing/2014/main" val="10000"/>
+                  </a:ext>
+                </a:extLst>
               </a:tr>
               <a:tr h="402336">
                 <a:tc>
@@ -12379,6 +13041,11 @@
                   </a:txBody>
                   <a:tcPr/>
                 </a:tc>
+                <a:extLst>
+                  <a:ext uri="{0D108BD9-81ED-4DB2-BD59-A6C34878D82A}">
+                    <a16:rowId xmlns:a16="http://schemas.microsoft.com/office/drawing/2014/main" val="10001"/>
+                  </a:ext>
+                </a:extLst>
               </a:tr>
               <a:tr h="402336">
                 <a:tc>
@@ -12429,6 +13096,11 @@
                     </a:solidFill>
                   </a:tcPr>
                 </a:tc>
+                <a:extLst>
+                  <a:ext uri="{0D108BD9-81ED-4DB2-BD59-A6C34878D82A}">
+                    <a16:rowId xmlns:a16="http://schemas.microsoft.com/office/drawing/2014/main" val="10002"/>
+                  </a:ext>
+                </a:extLst>
               </a:tr>
               <a:tr h="402336">
                 <a:tc>
@@ -12471,6 +13143,11 @@
                   </a:txBody>
                   <a:tcPr/>
                 </a:tc>
+                <a:extLst>
+                  <a:ext uri="{0D108BD9-81ED-4DB2-BD59-A6C34878D82A}">
+                    <a16:rowId xmlns:a16="http://schemas.microsoft.com/office/drawing/2014/main" val="10003"/>
+                  </a:ext>
+                </a:extLst>
               </a:tr>
               <a:tr h="402336">
                 <a:tc>
@@ -12521,6 +13198,11 @@
                     </a:solidFill>
                   </a:tcPr>
                 </a:tc>
+                <a:extLst>
+                  <a:ext uri="{0D108BD9-81ED-4DB2-BD59-A6C34878D82A}">
+                    <a16:rowId xmlns:a16="http://schemas.microsoft.com/office/drawing/2014/main" val="10004"/>
+                  </a:ext>
+                </a:extLst>
               </a:tr>
             </a:tbl>
           </a:graphicData>
@@ -12670,7 +13352,7 @@
 </file>
 
 <file path=ppt/slides/slide9.xml><?xml version="1.0" encoding="utf-8"?>
-<p:sld xmlns:a="http://schemas.openxmlformats.org/drawingml/2006/main" xmlns:p="http://schemas.openxmlformats.org/presentationml/2006/main" xmlns:r="http://schemas.openxmlformats.org/officeDocument/2006/relationships">
+<p:sld xmlns:a="http://schemas.openxmlformats.org/drawingml/2006/main" xmlns:r="http://schemas.openxmlformats.org/officeDocument/2006/relationships" xmlns:p="http://schemas.openxmlformats.org/presentationml/2006/main">
   <p:cSld>
     <p:bg>
       <p:bgPr>
@@ -12686,7 +13368,14 @@
         <p:cNvGrpSpPr/>
         <p:nvPr/>
       </p:nvGrpSpPr>
-      <p:grpSpPr/>
+      <p:grpSpPr>
+        <a:xfrm>
+          <a:off x="0" y="0"/>
+          <a:ext cx="0" cy="0"/>
+          <a:chOff x="0" y="0"/>
+          <a:chExt cx="0" cy="0"/>
+        </a:xfrm>
+      </p:grpSpPr>
       <p:sp>
         <p:nvSpPr>
           <p:cNvPr id="2" name="Rectangle 1"/>
@@ -12727,6 +13416,7 @@
           <a:lstStyle/>
           <a:p>
             <a:pPr algn="ctr"/>
+            <a:endParaRPr/>
           </a:p>
         </p:txBody>
       </p:sp>
@@ -12857,10 +13547,34 @@
                 <a:tableStyleId>{5C22544A-7EE6-4342-B048-85BDC9FD1C3A}</a:tableStyleId>
               </a:tblPr>
               <a:tblGrid>
-                <a:gridCol w="2743200"/>
-                <a:gridCol w="2743200"/>
-                <a:gridCol w="2743200"/>
-                <a:gridCol w="2743200"/>
+                <a:gridCol w="2743200">
+                  <a:extLst>
+                    <a:ext uri="{9D8B030D-6E8A-4147-A177-3AD203B41FA5}">
+                      <a16:colId xmlns:a16="http://schemas.microsoft.com/office/drawing/2014/main" val="20000"/>
+                    </a:ext>
+                  </a:extLst>
+                </a:gridCol>
+                <a:gridCol w="2743200">
+                  <a:extLst>
+                    <a:ext uri="{9D8B030D-6E8A-4147-A177-3AD203B41FA5}">
+                      <a16:colId xmlns:a16="http://schemas.microsoft.com/office/drawing/2014/main" val="20001"/>
+                    </a:ext>
+                  </a:extLst>
+                </a:gridCol>
+                <a:gridCol w="2743200">
+                  <a:extLst>
+                    <a:ext uri="{9D8B030D-6E8A-4147-A177-3AD203B41FA5}">
+                      <a16:colId xmlns:a16="http://schemas.microsoft.com/office/drawing/2014/main" val="20002"/>
+                    </a:ext>
+                  </a:extLst>
+                </a:gridCol>
+                <a:gridCol w="2743200">
+                  <a:extLst>
+                    <a:ext uri="{9D8B030D-6E8A-4147-A177-3AD203B41FA5}">
+                      <a16:colId xmlns:a16="http://schemas.microsoft.com/office/drawing/2014/main" val="20003"/>
+                    </a:ext>
+                  </a:extLst>
+                </a:gridCol>
               </a:tblGrid>
               <a:tr h="411480">
                 <a:tc>
@@ -12959,6 +13673,11 @@
                     </a:solidFill>
                   </a:tcPr>
                 </a:tc>
+                <a:extLst>
+                  <a:ext uri="{0D108BD9-81ED-4DB2-BD59-A6C34878D82A}">
+                    <a16:rowId xmlns:a16="http://schemas.microsoft.com/office/drawing/2014/main" val="10000"/>
+                  </a:ext>
+                </a:extLst>
               </a:tr>
               <a:tr h="411480">
                 <a:tc>
@@ -13041,6 +13760,11 @@
                   </a:txBody>
                   <a:tcPr/>
                 </a:tc>
+                <a:extLst>
+                  <a:ext uri="{0D108BD9-81ED-4DB2-BD59-A6C34878D82A}">
+                    <a16:rowId xmlns:a16="http://schemas.microsoft.com/office/drawing/2014/main" val="10001"/>
+                  </a:ext>
+                </a:extLst>
               </a:tr>
               <a:tr h="411480">
                 <a:tc>
@@ -13139,6 +13863,11 @@
                     </a:solidFill>
                   </a:tcPr>
                 </a:tc>
+                <a:extLst>
+                  <a:ext uri="{0D108BD9-81ED-4DB2-BD59-A6C34878D82A}">
+                    <a16:rowId xmlns:a16="http://schemas.microsoft.com/office/drawing/2014/main" val="10002"/>
+                  </a:ext>
+                </a:extLst>
               </a:tr>
               <a:tr h="411480">
                 <a:tc>
@@ -13221,6 +13950,11 @@
                   </a:txBody>
                   <a:tcPr/>
                 </a:tc>
+                <a:extLst>
+                  <a:ext uri="{0D108BD9-81ED-4DB2-BD59-A6C34878D82A}">
+                    <a16:rowId xmlns:a16="http://schemas.microsoft.com/office/drawing/2014/main" val="10003"/>
+                  </a:ext>
+                </a:extLst>
               </a:tr>
             </a:tbl>
           </a:graphicData>
@@ -13416,10 +14150,34 @@
                 <a:tableStyleId>{5C22544A-7EE6-4342-B048-85BDC9FD1C3A}</a:tableStyleId>
               </a:tblPr>
               <a:tblGrid>
-                <a:gridCol w="1257300"/>
-                <a:gridCol w="1257300"/>
-                <a:gridCol w="1257300"/>
-                <a:gridCol w="1257300"/>
+                <a:gridCol w="1257300">
+                  <a:extLst>
+                    <a:ext uri="{9D8B030D-6E8A-4147-A177-3AD203B41FA5}">
+                      <a16:colId xmlns:a16="http://schemas.microsoft.com/office/drawing/2014/main" val="20000"/>
+                    </a:ext>
+                  </a:extLst>
+                </a:gridCol>
+                <a:gridCol w="1257300">
+                  <a:extLst>
+                    <a:ext uri="{9D8B030D-6E8A-4147-A177-3AD203B41FA5}">
+                      <a16:colId xmlns:a16="http://schemas.microsoft.com/office/drawing/2014/main" val="20001"/>
+                    </a:ext>
+                  </a:extLst>
+                </a:gridCol>
+                <a:gridCol w="1257300">
+                  <a:extLst>
+                    <a:ext uri="{9D8B030D-6E8A-4147-A177-3AD203B41FA5}">
+                      <a16:colId xmlns:a16="http://schemas.microsoft.com/office/drawing/2014/main" val="20002"/>
+                    </a:ext>
+                  </a:extLst>
+                </a:gridCol>
+                <a:gridCol w="1257300">
+                  <a:extLst>
+                    <a:ext uri="{9D8B030D-6E8A-4147-A177-3AD203B41FA5}">
+                      <a16:colId xmlns:a16="http://schemas.microsoft.com/office/drawing/2014/main" val="20003"/>
+                    </a:ext>
+                  </a:extLst>
+                </a:gridCol>
               </a:tblGrid>
               <a:tr h="411480">
                 <a:tc>
@@ -13518,6 +14276,11 @@
                     </a:solidFill>
                   </a:tcPr>
                 </a:tc>
+                <a:extLst>
+                  <a:ext uri="{0D108BD9-81ED-4DB2-BD59-A6C34878D82A}">
+                    <a16:rowId xmlns:a16="http://schemas.microsoft.com/office/drawing/2014/main" val="10000"/>
+                  </a:ext>
+                </a:extLst>
               </a:tr>
               <a:tr h="411480">
                 <a:tc>
@@ -13600,6 +14363,11 @@
                   </a:txBody>
                   <a:tcPr/>
                 </a:tc>
+                <a:extLst>
+                  <a:ext uri="{0D108BD9-81ED-4DB2-BD59-A6C34878D82A}">
+                    <a16:rowId xmlns:a16="http://schemas.microsoft.com/office/drawing/2014/main" val="10001"/>
+                  </a:ext>
+                </a:extLst>
               </a:tr>
               <a:tr h="411480">
                 <a:tc>
@@ -13698,6 +14466,11 @@
                     </a:solidFill>
                   </a:tcPr>
                 </a:tc>
+                <a:extLst>
+                  <a:ext uri="{0D108BD9-81ED-4DB2-BD59-A6C34878D82A}">
+                    <a16:rowId xmlns:a16="http://schemas.microsoft.com/office/drawing/2014/main" val="10002"/>
+                  </a:ext>
+                </a:extLst>
               </a:tr>
               <a:tr h="411480">
                 <a:tc>
@@ -13780,6 +14553,11 @@
                   </a:txBody>
                   <a:tcPr/>
                 </a:tc>
+                <a:extLst>
+                  <a:ext uri="{0D108BD9-81ED-4DB2-BD59-A6C34878D82A}">
+                    <a16:rowId xmlns:a16="http://schemas.microsoft.com/office/drawing/2014/main" val="10003"/>
+                  </a:ext>
+                </a:extLst>
               </a:tr>
             </a:tbl>
           </a:graphicData>

</xml_diff>